<commit_message>
Break-descent complete: hardware x band break map, analysis, deck Part 3 (slides 13-14)
Co-Authored-By: Claude Fable 5 <noreply@anthropic.com>
</commit_message>
<xml_diff>
--- a/presentation/Frequency_Reduction.pptx
+++ b/presentation/Frequency_Reduction.pptx
@@ -17,9 +17,11 @@
     <p:sldId id="265" r:id="rId11"/>
     <p:sldId id="266" r:id="rId12"/>
     <p:sldId id="267" r:id="rId13"/>
+    <p:sldId id="268" r:id="rId14"/>
+    <p:sldId id="269" r:id="rId15"/>
   </p:sldIdLst>
   <p:notesMasterIdLst>
-    <p:notesMasterId r:id="rId14"/>
+    <p:notesMasterId r:id="rId16"/>
   </p:notesMasterIdLst>
   <p:sldSz cx="9144000" cy="5143500"/>
   <p:notesSz cx="5143500" cy="9144000"/>
@@ -801,6 +803,182 @@
             <a:fld id="{F7021451-1387-4CA6-816F-3879F97B5CBC}" type="slidenum">
               <a:rPr lang="en-US"/>
               <a:t>12</a:t>
+            </a:fld>
+            <a:endParaRPr lang="en-US"/>
+          </a:p>
+        </p:txBody>
+      </p:sp>
+    </p:spTree>
+    <p:extLst>
+      <p:ext uri="{BB962C8B-B14F-4D97-AF65-F5344CB8AC3E}">
+        <p14:creationId xmlns:p14="http://schemas.microsoft.com/office/powerpoint/2010/main" val="1024086991"/>
+      </p:ext>
+    </p:extLst>
+  </p:cSld>
+  <p:clrMapOvr>
+    <a:masterClrMapping/>
+  </p:clrMapOvr>
+</p:notes>
+</file>
+
+<file path=ppt/notesSlides/notesSlide13.xml><?xml version="1.0" encoding="utf-8"?>
+<p:notes xmlns:a="http://schemas.openxmlformats.org/drawingml/2006/main" xmlns:r="http://schemas.openxmlformats.org/officeDocument/2006/relationships" xmlns:p="http://schemas.openxmlformats.org/presentationml/2006/main">
+  <p:cSld>
+    <p:spTree>
+      <p:nvGrpSpPr>
+        <p:cNvPr id="1" name=""/>
+        <p:cNvGrpSpPr/>
+        <p:nvPr/>
+      </p:nvGrpSpPr>
+      <p:grpSpPr>
+        <a:xfrm>
+          <a:off x="0" y="0"/>
+          <a:ext cx="0" cy="0"/>
+          <a:chOff x="0" y="0"/>
+          <a:chExt cx="0" cy="0"/>
+        </a:xfrm>
+      </p:grpSpPr>
+      <p:sp>
+        <p:nvSpPr>
+          <p:cNvPr id="2" name="Slide Image Placeholder 1"/>
+          <p:cNvSpPr>
+            <a:spLocks noGrp="1" noRot="1" noChangeAspect="1"/>
+          </p:cNvSpPr>
+          <p:nvPr>
+            <p:ph type="sldImg"/>
+          </p:nvPr>
+        </p:nvSpPr>
+        <p:spPr/>
+      </p:sp>
+      <p:sp>
+        <p:nvSpPr>
+          <p:cNvPr id="3" name="Notes Placeholder 2"/>
+          <p:cNvSpPr>
+            <a:spLocks noGrp="1"/>
+          </p:cNvSpPr>
+          <p:nvPr>
+            <p:ph type="body" idx="1"/>
+          </p:nvPr>
+        </p:nvSpPr>
+        <p:spPr/>
+        <p:txBody>
+          <a:bodyPr/>
+          <a:lstStyle/>
+          <a:p>
+            <a:r>
+              <a:rPr lang="en-US" dirty="0"/>
+              <a:t/>
+            </a:r>
+            <a:endParaRPr lang="en-US" dirty="0"/>
+          </a:p>
+        </p:txBody>
+      </p:sp>
+      <p:sp>
+        <p:nvSpPr>
+          <p:cNvPr id="4" name="Slide Number Placeholder 3"/>
+          <p:cNvSpPr>
+            <a:spLocks noGrp="1"/>
+          </p:cNvSpPr>
+          <p:nvPr>
+            <p:ph type="sldNum" sz="quarter" idx="10"/>
+          </p:nvPr>
+        </p:nvSpPr>
+        <p:spPr/>
+        <p:txBody>
+          <a:bodyPr/>
+          <a:lstStyle/>
+          <a:p>
+            <a:fld id="{F7021451-1387-4CA6-816F-3879F97B5CBC}" type="slidenum">
+              <a:rPr lang="en-US"/>
+              <a:t>13</a:t>
+            </a:fld>
+            <a:endParaRPr lang="en-US"/>
+          </a:p>
+        </p:txBody>
+      </p:sp>
+    </p:spTree>
+    <p:extLst>
+      <p:ext uri="{BB962C8B-B14F-4D97-AF65-F5344CB8AC3E}">
+        <p14:creationId xmlns:p14="http://schemas.microsoft.com/office/powerpoint/2010/main" val="1024086991"/>
+      </p:ext>
+    </p:extLst>
+  </p:cSld>
+  <p:clrMapOvr>
+    <a:masterClrMapping/>
+  </p:clrMapOvr>
+</p:notes>
+</file>
+
+<file path=ppt/notesSlides/notesSlide14.xml><?xml version="1.0" encoding="utf-8"?>
+<p:notes xmlns:a="http://schemas.openxmlformats.org/drawingml/2006/main" xmlns:r="http://schemas.openxmlformats.org/officeDocument/2006/relationships" xmlns:p="http://schemas.openxmlformats.org/presentationml/2006/main">
+  <p:cSld>
+    <p:spTree>
+      <p:nvGrpSpPr>
+        <p:cNvPr id="1" name=""/>
+        <p:cNvGrpSpPr/>
+        <p:nvPr/>
+      </p:nvGrpSpPr>
+      <p:grpSpPr>
+        <a:xfrm>
+          <a:off x="0" y="0"/>
+          <a:ext cx="0" cy="0"/>
+          <a:chOff x="0" y="0"/>
+          <a:chExt cx="0" cy="0"/>
+        </a:xfrm>
+      </p:grpSpPr>
+      <p:sp>
+        <p:nvSpPr>
+          <p:cNvPr id="2" name="Slide Image Placeholder 1"/>
+          <p:cNvSpPr>
+            <a:spLocks noGrp="1" noRot="1" noChangeAspect="1"/>
+          </p:cNvSpPr>
+          <p:nvPr>
+            <p:ph type="sldImg"/>
+          </p:nvPr>
+        </p:nvSpPr>
+        <p:spPr/>
+      </p:sp>
+      <p:sp>
+        <p:nvSpPr>
+          <p:cNvPr id="3" name="Notes Placeholder 2"/>
+          <p:cNvSpPr>
+            <a:spLocks noGrp="1"/>
+          </p:cNvSpPr>
+          <p:nvPr>
+            <p:ph type="body" idx="1"/>
+          </p:nvPr>
+        </p:nvSpPr>
+        <p:spPr/>
+        <p:txBody>
+          <a:bodyPr/>
+          <a:lstStyle/>
+          <a:p>
+            <a:r>
+              <a:rPr lang="en-US" dirty="0"/>
+              <a:t/>
+            </a:r>
+            <a:endParaRPr lang="en-US" dirty="0"/>
+          </a:p>
+        </p:txBody>
+      </p:sp>
+      <p:sp>
+        <p:nvSpPr>
+          <p:cNvPr id="4" name="Slide Number Placeholder 3"/>
+          <p:cNvSpPr>
+            <a:spLocks noGrp="1"/>
+          </p:cNvSpPr>
+          <p:nvPr>
+            <p:ph type="sldNum" sz="quarter" idx="10"/>
+          </p:nvPr>
+        </p:nvSpPr>
+        <p:spPr/>
+        <p:txBody>
+          <a:bodyPr/>
+          <a:lstStyle/>
+          <a:p>
+            <a:fld id="{F7021451-1387-4CA6-816F-3879F97B5CBC}" type="slidenum">
+              <a:rPr lang="en-US"/>
+              <a:t>14</a:t>
             </a:fld>
             <a:endParaRPr lang="en-US"/>
           </a:p>
@@ -6955,7 +7133,2078 @@
                 <a:ea typeface="Calibri" pitchFamily="34" charset="-122"/>
                 <a:cs typeface="Calibri" pitchFamily="34" charset="-120"/>
               </a:rPr>
-              <a:t>With all 16 S-parameters and a well-placed window, bandwidth alone cannot push any phantom below 50%: even a 50 MHz sliver holds 99 / 90 / 60. F5 fails softly (degraded, then session-unstable below 1 GHz). Breaking for real requires combining the band cut with hardware reduction; that adaptive descent (reflection-only, fewer antennas) is running now.</a:t>
+              <a:t>With all 16 S-parameters and a well-placed window, bandwidth alone cannot push any phantom below 50%: even a 50 MHz sliver holds 99 / 90 / 60. F5 fails softly (degraded, then session-unstable below 1 GHz). Breaking for real requires combining the band cut with hardware reduction; that adaptive descent is Part 3.</a:t>
+            </a:r>
+            <a:endParaRPr lang="en-US" sz="1250" dirty="0"/>
+          </a:p>
+        </p:txBody>
+      </p:sp>
+    </p:spTree>
+  </p:cSld>
+  <p:clrMapOvr>
+    <a:masterClrMapping/>
+  </p:clrMapOvr>
+</p:sld>
+</file>
+
+<file path=ppt/slides/slide13.xml><?xml version="1.0" encoding="utf-8"?>
+<p:sld xmlns:a="http://schemas.openxmlformats.org/drawingml/2006/main" xmlns:r="http://schemas.openxmlformats.org/officeDocument/2006/relationships" xmlns:p="http://schemas.openxmlformats.org/presentationml/2006/main">
+  <p:cSld name="Slide 13">
+    <p:bg>
+      <p:bgPr>
+        <a:solidFill>
+          <a:srgbClr val="FFFFFF"/>
+        </a:solidFill>
+      </p:bgPr>
+    </p:bg>
+    <p:spTree>
+      <p:nvGrpSpPr>
+        <p:cNvPr id="1" name=""/>
+        <p:cNvGrpSpPr/>
+        <p:nvPr/>
+      </p:nvGrpSpPr>
+      <p:grpSpPr>
+        <a:xfrm>
+          <a:off x="0" y="0"/>
+          <a:ext cx="0" cy="0"/>
+          <a:chOff x="0" y="0"/>
+          <a:chExt cx="0" cy="0"/>
+        </a:xfrm>
+      </p:grpSpPr>
+      <p:sp>
+        <p:nvSpPr>
+          <p:cNvPr id="2" name="Text 0"/>
+          <p:cNvSpPr/>
+          <p:nvPr/>
+        </p:nvSpPr>
+        <p:spPr>
+          <a:xfrm>
+            <a:off x="457200" y="237744"/>
+            <a:ext cx="8229600" cy="256032"/>
+          </a:xfrm>
+          <a:prstGeom prst="rect">
+            <a:avLst/>
+          </a:prstGeom>
+          <a:noFill/>
+          <a:ln/>
+        </p:spPr>
+        <p:txBody>
+          <a:bodyPr wrap="square" lIns="0" tIns="0" rIns="0" bIns="0" rtlCol="0" anchor="t"/>
+          <a:lstStyle/>
+          <a:p>
+            <a:pPr indent="0" marL="0">
+              <a:buNone/>
+            </a:pPr>
+            <a:r>
+              <a:rPr lang="en-US" sz="1200" b="1" spc="200" kern="0" dirty="0">
+                <a:solidFill>
+                  <a:srgbClr val="BE0000"/>
+                </a:solidFill>
+                <a:latin typeface="Calibri" pitchFamily="34" charset="0"/>
+                <a:ea typeface="Calibri" pitchFamily="34" charset="-122"/>
+                <a:cs typeface="Calibri" pitchFamily="34" charset="-120"/>
+              </a:rPr>
+              <a:t>PART 3 · HARDWARE + BAND TOGETHER</a:t>
+            </a:r>
+            <a:endParaRPr lang="en-US" sz="1200" dirty="0"/>
+          </a:p>
+        </p:txBody>
+      </p:sp>
+      <p:sp>
+        <p:nvSpPr>
+          <p:cNvPr id="3" name="Text 1"/>
+          <p:cNvSpPr/>
+          <p:nvPr/>
+        </p:nvSpPr>
+        <p:spPr>
+          <a:xfrm>
+            <a:off x="457200" y="512064"/>
+            <a:ext cx="8229600" cy="548640"/>
+          </a:xfrm>
+          <a:prstGeom prst="rect">
+            <a:avLst/>
+          </a:prstGeom>
+          <a:noFill/>
+          <a:ln/>
+        </p:spPr>
+        <p:txBody>
+          <a:bodyPr wrap="square" lIns="0" tIns="0" rIns="0" bIns="0" rtlCol="0" anchor="t"/>
+          <a:lstStyle/>
+          <a:p>
+            <a:pPr indent="0" marL="0">
+              <a:buNone/>
+            </a:pPr>
+            <a:r>
+              <a:rPr lang="en-US" sz="2500" b="1" dirty="0">
+                <a:solidFill>
+                  <a:srgbClr val="2A1618"/>
+                </a:solidFill>
+                <a:latin typeface="Cambria" pitchFamily="34" charset="0"/>
+                <a:ea typeface="Cambria" pitchFamily="34" charset="-122"/>
+                <a:cs typeface="Cambria" pitchFamily="34" charset="-120"/>
+              </a:rPr>
+              <a:t>The full break map: 5 hardware levels x 7 bands</a:t>
+            </a:r>
+            <a:endParaRPr lang="en-US" sz="2500" dirty="0"/>
+          </a:p>
+        </p:txBody>
+      </p:sp>
+      <p:pic>
+        <p:nvPicPr>
+          <p:cNvPr id="4" name="Image 0" descr="assets/break_descent_map.png">    </p:cNvPr>
+          <p:cNvPicPr>
+            <a:picLocks noChangeAspect="1"/>
+          </p:cNvPicPr>
+          <p:nvPr/>
+        </p:nvPicPr>
+        <p:blipFill>
+          <a:blip r:embed="rId1"/>
+          <a:stretch>
+            <a:fillRect/>
+          </a:stretch>
+        </p:blipFill>
+        <p:spPr>
+          <a:xfrm>
+            <a:off x="228600" y="1417320"/>
+            <a:ext cx="8686800" cy="2578608"/>
+          </a:xfrm>
+          <a:prstGeom prst="rect">
+            <a:avLst/>
+          </a:prstGeom>
+        </p:spPr>
+      </p:pic>
+      <p:sp>
+        <p:nvSpPr>
+          <p:cNvPr id="5" name="Shape 2"/>
+          <p:cNvSpPr/>
+          <p:nvPr/>
+        </p:nvSpPr>
+        <p:spPr>
+          <a:xfrm>
+            <a:off x="457200" y="4224528"/>
+            <a:ext cx="8229600" cy="777240"/>
+          </a:xfrm>
+          <a:prstGeom prst="roundRect">
+            <a:avLst>
+              <a:gd name="adj" fmla="val 7059"/>
+            </a:avLst>
+          </a:prstGeom>
+          <a:solidFill>
+            <a:srgbClr val="FBEDED"/>
+          </a:solidFill>
+          <a:ln w="12700">
+            <a:solidFill>
+              <a:srgbClr val="E8C4C4"/>
+            </a:solidFill>
+            <a:prstDash val="solid"/>
+          </a:ln>
+        </p:spPr>
+      </p:sp>
+      <p:sp>
+        <p:nvSpPr>
+          <p:cNvPr id="6" name="Text 3"/>
+          <p:cNvSpPr/>
+          <p:nvPr/>
+        </p:nvSpPr>
+        <p:spPr>
+          <a:xfrm>
+            <a:off x="658368" y="4224528"/>
+            <a:ext cx="7863840" cy="777240"/>
+          </a:xfrm>
+          <a:prstGeom prst="rect">
+            <a:avLst/>
+          </a:prstGeom>
+          <a:noFill/>
+          <a:ln/>
+        </p:spPr>
+        <p:txBody>
+          <a:bodyPr wrap="square" lIns="0" tIns="0" rIns="0" bIns="0" rtlCol="0" anchor="ctr"/>
+          <a:lstStyle/>
+          <a:p>
+            <a:pPr indent="0" marL="0">
+              <a:buNone/>
+            </a:pPr>
+            <a:r>
+              <a:rPr lang="en-US" sz="1200" dirty="0">
+                <a:solidFill>
+                  <a:srgbClr val="2B2B2B"/>
+                </a:solidFill>
+                <a:latin typeface="Calibri" pitchFamily="34" charset="0"/>
+                <a:ea typeface="Calibri" pitchFamily="34" charset="-122"/>
+                <a:cs typeface="Calibri" pitchFamily="34" charset="-120"/>
+              </a:rPr>
+              <a:t>Adaptive descent: bands narrow left to right at the best placement per width; once a phantom scores below 50% (black box) it stops descending at that hardware level. Blank cells were skipped after the break. Empty stays green everywhere.</a:t>
+            </a:r>
+            <a:endParaRPr lang="en-US" sz="1200" dirty="0"/>
+          </a:p>
+        </p:txBody>
+      </p:sp>
+    </p:spTree>
+  </p:cSld>
+  <p:clrMapOvr>
+    <a:masterClrMapping/>
+  </p:clrMapOvr>
+</p:sld>
+</file>
+
+<file path=ppt/slides/slide14.xml><?xml version="1.0" encoding="utf-8"?>
+<p:sld xmlns:a="http://schemas.openxmlformats.org/drawingml/2006/main" xmlns:r="http://schemas.openxmlformats.org/officeDocument/2006/relationships" xmlns:p="http://schemas.openxmlformats.org/presentationml/2006/main">
+  <p:cSld name="Slide 14">
+    <p:bg>
+      <p:bgPr>
+        <a:solidFill>
+          <a:srgbClr val="FFFFFF"/>
+        </a:solidFill>
+      </p:bgPr>
+    </p:bg>
+    <p:spTree>
+      <p:nvGrpSpPr>
+        <p:cNvPr id="1" name=""/>
+        <p:cNvGrpSpPr/>
+        <p:nvPr/>
+      </p:nvGrpSpPr>
+      <p:grpSpPr>
+        <a:xfrm>
+          <a:off x="0" y="0"/>
+          <a:ext cx="0" cy="0"/>
+          <a:chOff x="0" y="0"/>
+          <a:chExt cx="0" cy="0"/>
+        </a:xfrm>
+      </p:grpSpPr>
+      <p:sp>
+        <p:nvSpPr>
+          <p:cNvPr id="2" name="Text 0"/>
+          <p:cNvSpPr/>
+          <p:nvPr/>
+        </p:nvSpPr>
+        <p:spPr>
+          <a:xfrm>
+            <a:off x="457200" y="237744"/>
+            <a:ext cx="8229600" cy="256032"/>
+          </a:xfrm>
+          <a:prstGeom prst="rect">
+            <a:avLst/>
+          </a:prstGeom>
+          <a:noFill/>
+          <a:ln/>
+        </p:spPr>
+        <p:txBody>
+          <a:bodyPr wrap="square" lIns="0" tIns="0" rIns="0" bIns="0" rtlCol="0" anchor="t"/>
+          <a:lstStyle/>
+          <a:p>
+            <a:pPr indent="0" marL="0">
+              <a:buNone/>
+            </a:pPr>
+            <a:r>
+              <a:rPr lang="en-US" sz="1200" b="1" spc="200" kern="0" dirty="0">
+                <a:solidFill>
+                  <a:srgbClr val="BE0000"/>
+                </a:solidFill>
+                <a:latin typeface="Calibri" pitchFamily="34" charset="0"/>
+                <a:ea typeface="Calibri" pitchFamily="34" charset="-122"/>
+                <a:cs typeface="Calibri" pitchFamily="34" charset="-120"/>
+              </a:rPr>
+              <a:t>PART 3 · VERDICT</a:t>
+            </a:r>
+            <a:endParaRPr lang="en-US" sz="1200" dirty="0"/>
+          </a:p>
+        </p:txBody>
+      </p:sp>
+      <p:sp>
+        <p:nvSpPr>
+          <p:cNvPr id="3" name="Text 1"/>
+          <p:cNvSpPr/>
+          <p:nvPr/>
+        </p:nvSpPr>
+        <p:spPr>
+          <a:xfrm>
+            <a:off x="457200" y="512064"/>
+            <a:ext cx="8229600" cy="548640"/>
+          </a:xfrm>
+          <a:prstGeom prst="rect">
+            <a:avLst/>
+          </a:prstGeom>
+          <a:noFill/>
+          <a:ln/>
+        </p:spPr>
+        <p:txBody>
+          <a:bodyPr wrap="square" lIns="0" tIns="0" rIns="0" bIns="0" rtlCol="0" anchor="t"/>
+          <a:lstStyle/>
+          <a:p>
+            <a:pPr indent="0" marL="0">
+              <a:buNone/>
+            </a:pPr>
+            <a:r>
+              <a:rPr lang="en-US" sz="2500" b="1" dirty="0">
+                <a:solidFill>
+                  <a:srgbClr val="2A1618"/>
+                </a:solidFill>
+                <a:latin typeface="Cambria" pitchFamily="34" charset="0"/>
+                <a:ea typeface="Cambria" pitchFamily="34" charset="-122"/>
+                <a:cs typeface="Cambria" pitchFamily="34" charset="-120"/>
+              </a:rPr>
+              <a:t>Where each phantom finally breaks (&lt;50%)</a:t>
+            </a:r>
+            <a:endParaRPr lang="en-US" sz="2500" dirty="0"/>
+          </a:p>
+        </p:txBody>
+      </p:sp>
+      <p:graphicFrame>
+        <p:nvGraphicFramePr>
+          <p:cNvPr id="15" name="Table 0"/>
+          <p:cNvGraphicFramePr>
+            <a:graphicFrameLocks noGrp="1"/>
+          </p:cNvGraphicFramePr>
+          <p:nvPr>
+            <p:extLst>
+              <p:ext uri="{D42A27DB-BD31-4B8C-83A1-F6EECF244321}">
+                <p14:modId xmlns:p14="http://schemas.microsoft.com/office/powerpoint/2010/main" val="1579011935"/>
+              </p:ext>
+            </p:extLst>
+          </p:nvPr>
+        </p:nvGraphicFramePr>
+        <p:xfrm>
+          <a:off x="457200" y="1325880"/>
+          <a:ext cx="8229600" cy="914400"/>
+        </p:xfrm>
+        <a:graphic>
+          <a:graphicData uri="http://schemas.openxmlformats.org/drawingml/2006/table">
+            <a:tbl>
+              <a:tblPr/>
+              <a:tblGrid>
+                <a:gridCol w="3383280"/>
+                <a:gridCol w="1554480"/>
+                <a:gridCol w="1554480"/>
+                <a:gridCol w="1737360"/>
+              </a:tblGrid>
+              <a:tr h="384048">
+                <a:tc>
+                  <a:txBody>
+                    <a:bodyPr/>
+                    <a:lstStyle/>
+                    <a:p>
+                      <a:pPr algn="ctr" indent="0" marL="0">
+                        <a:buNone/>
+                      </a:pPr>
+                      <a:r>
+                        <a:rPr lang="en-US" sz="1250" b="1" dirty="0">
+                          <a:solidFill>
+                            <a:srgbClr val="FFFFFF"/>
+                          </a:solidFill>
+                          <a:latin typeface="Calibri" pitchFamily="34" charset="0"/>
+                          <a:ea typeface="Calibri" pitchFamily="34" charset="-122"/>
+                          <a:cs typeface="Calibri" pitchFamily="34" charset="-120"/>
+                        </a:rPr>
+                        <a:t>Hardware</a:t>
+                      </a:r>
+                      <a:endParaRPr lang="en-US" sz="1250" dirty="0">
+                        <a:latin typeface="Calibri" charset="0"/>
+                        <a:ea typeface="Calibri" charset="0"/>
+                        <a:cs typeface="Calibri" charset="0"/>
+                      </a:endParaRPr>
+                    </a:p>
+                  </a:txBody>
+                  <a:tcPr marL="91440" marR="91440" marT="45720" marB="45720" anchor="ctr">
+                    <a:lnL w="9525" cap="flat" cmpd="sng" algn="ctr">
+                      <a:solidFill>
+                        <a:srgbClr val="D9D9D9"/>
+                      </a:solidFill>
+                      <a:prstDash val="solid"/>
+                      <a:round/>
+                      <a:headEnd type="none" w="med" len="med"/>
+                      <a:tailEnd type="none" w="med" len="med"/>
+                    </a:lnL>
+                    <a:lnR w="9525" cap="flat" cmpd="sng" algn="ctr">
+                      <a:solidFill>
+                        <a:srgbClr val="D9D9D9"/>
+                      </a:solidFill>
+                      <a:prstDash val="solid"/>
+                      <a:round/>
+                      <a:headEnd type="none" w="med" len="med"/>
+                      <a:tailEnd type="none" w="med" len="med"/>
+                    </a:lnR>
+                    <a:lnT w="9525" cap="flat" cmpd="sng" algn="ctr">
+                      <a:solidFill>
+                        <a:srgbClr val="D9D9D9"/>
+                      </a:solidFill>
+                      <a:prstDash val="solid"/>
+                      <a:round/>
+                      <a:headEnd type="none" w="med" len="med"/>
+                      <a:tailEnd type="none" w="med" len="med"/>
+                    </a:lnT>
+                    <a:lnB w="9525" cap="flat" cmpd="sng" algn="ctr">
+                      <a:solidFill>
+                        <a:srgbClr val="D9D9D9"/>
+                      </a:solidFill>
+                      <a:prstDash val="solid"/>
+                      <a:round/>
+                      <a:headEnd type="none" w="med" len="med"/>
+                      <a:tailEnd type="none" w="med" len="med"/>
+                    </a:lnB>
+                    <a:solidFill>
+                      <a:srgbClr val="BE0000"/>
+                    </a:solidFill>
+                  </a:tcPr>
+                </a:tc>
+                <a:tc>
+                  <a:txBody>
+                    <a:bodyPr/>
+                    <a:lstStyle/>
+                    <a:p>
+                      <a:pPr algn="ctr" indent="0" marL="0">
+                        <a:buNone/>
+                      </a:pPr>
+                      <a:r>
+                        <a:rPr lang="en-US" sz="1250" b="1" dirty="0">
+                          <a:solidFill>
+                            <a:srgbClr val="FFFFFF"/>
+                          </a:solidFill>
+                          <a:latin typeface="Calibri" pitchFamily="34" charset="0"/>
+                          <a:ea typeface="Calibri" pitchFamily="34" charset="-122"/>
+                          <a:cs typeface="Calibri" pitchFamily="34" charset="-120"/>
+                        </a:rPr>
+                        <a:t>Empty</a:t>
+                      </a:r>
+                      <a:endParaRPr lang="en-US" sz="1250" dirty="0">
+                        <a:latin typeface="Calibri" charset="0"/>
+                        <a:ea typeface="Calibri" charset="0"/>
+                        <a:cs typeface="Calibri" charset="0"/>
+                      </a:endParaRPr>
+                    </a:p>
+                  </a:txBody>
+                  <a:tcPr marL="91440" marR="91440" marT="45720" marB="45720" anchor="ctr">
+                    <a:lnL w="9525" cap="flat" cmpd="sng" algn="ctr">
+                      <a:solidFill>
+                        <a:srgbClr val="D9D9D9"/>
+                      </a:solidFill>
+                      <a:prstDash val="solid"/>
+                      <a:round/>
+                      <a:headEnd type="none" w="med" len="med"/>
+                      <a:tailEnd type="none" w="med" len="med"/>
+                    </a:lnL>
+                    <a:lnR w="9525" cap="flat" cmpd="sng" algn="ctr">
+                      <a:solidFill>
+                        <a:srgbClr val="D9D9D9"/>
+                      </a:solidFill>
+                      <a:prstDash val="solid"/>
+                      <a:round/>
+                      <a:headEnd type="none" w="med" len="med"/>
+                      <a:tailEnd type="none" w="med" len="med"/>
+                    </a:lnR>
+                    <a:lnT w="9525" cap="flat" cmpd="sng" algn="ctr">
+                      <a:solidFill>
+                        <a:srgbClr val="D9D9D9"/>
+                      </a:solidFill>
+                      <a:prstDash val="solid"/>
+                      <a:round/>
+                      <a:headEnd type="none" w="med" len="med"/>
+                      <a:tailEnd type="none" w="med" len="med"/>
+                    </a:lnT>
+                    <a:lnB w="9525" cap="flat" cmpd="sng" algn="ctr">
+                      <a:solidFill>
+                        <a:srgbClr val="D9D9D9"/>
+                      </a:solidFill>
+                      <a:prstDash val="solid"/>
+                      <a:round/>
+                      <a:headEnd type="none" w="med" len="med"/>
+                      <a:tailEnd type="none" w="med" len="med"/>
+                    </a:lnB>
+                    <a:solidFill>
+                      <a:srgbClr val="BE0000"/>
+                    </a:solidFill>
+                  </a:tcPr>
+                </a:tc>
+                <a:tc>
+                  <a:txBody>
+                    <a:bodyPr/>
+                    <a:lstStyle/>
+                    <a:p>
+                      <a:pPr algn="ctr" indent="0" marL="0">
+                        <a:buNone/>
+                      </a:pPr>
+                      <a:r>
+                        <a:rPr lang="en-US" sz="1250" b="1" dirty="0">
+                          <a:solidFill>
+                            <a:srgbClr val="FFFFFF"/>
+                          </a:solidFill>
+                          <a:latin typeface="Calibri" pitchFamily="34" charset="0"/>
+                          <a:ea typeface="Calibri" pitchFamily="34" charset="-122"/>
+                          <a:cs typeface="Calibri" pitchFamily="34" charset="-120"/>
+                        </a:rPr>
+                        <a:t>A3 + F4</a:t>
+                      </a:r>
+                      <a:endParaRPr lang="en-US" sz="1250" dirty="0">
+                        <a:latin typeface="Calibri" charset="0"/>
+                        <a:ea typeface="Calibri" charset="0"/>
+                        <a:cs typeface="Calibri" charset="0"/>
+                      </a:endParaRPr>
+                    </a:p>
+                  </a:txBody>
+                  <a:tcPr marL="91440" marR="91440" marT="45720" marB="45720" anchor="ctr">
+                    <a:lnL w="9525" cap="flat" cmpd="sng" algn="ctr">
+                      <a:solidFill>
+                        <a:srgbClr val="D9D9D9"/>
+                      </a:solidFill>
+                      <a:prstDash val="solid"/>
+                      <a:round/>
+                      <a:headEnd type="none" w="med" len="med"/>
+                      <a:tailEnd type="none" w="med" len="med"/>
+                    </a:lnL>
+                    <a:lnR w="9525" cap="flat" cmpd="sng" algn="ctr">
+                      <a:solidFill>
+                        <a:srgbClr val="D9D9D9"/>
+                      </a:solidFill>
+                      <a:prstDash val="solid"/>
+                      <a:round/>
+                      <a:headEnd type="none" w="med" len="med"/>
+                      <a:tailEnd type="none" w="med" len="med"/>
+                    </a:lnR>
+                    <a:lnT w="9525" cap="flat" cmpd="sng" algn="ctr">
+                      <a:solidFill>
+                        <a:srgbClr val="D9D9D9"/>
+                      </a:solidFill>
+                      <a:prstDash val="solid"/>
+                      <a:round/>
+                      <a:headEnd type="none" w="med" len="med"/>
+                      <a:tailEnd type="none" w="med" len="med"/>
+                    </a:lnT>
+                    <a:lnB w="9525" cap="flat" cmpd="sng" algn="ctr">
+                      <a:solidFill>
+                        <a:srgbClr val="D9D9D9"/>
+                      </a:solidFill>
+                      <a:prstDash val="solid"/>
+                      <a:round/>
+                      <a:headEnd type="none" w="med" len="med"/>
+                      <a:tailEnd type="none" w="med" len="med"/>
+                    </a:lnB>
+                    <a:solidFill>
+                      <a:srgbClr val="BE0000"/>
+                    </a:solidFill>
+                  </a:tcPr>
+                </a:tc>
+                <a:tc>
+                  <a:txBody>
+                    <a:bodyPr/>
+                    <a:lstStyle/>
+                    <a:p>
+                      <a:pPr algn="ctr" indent="0" marL="0">
+                        <a:buNone/>
+                      </a:pPr>
+                      <a:r>
+                        <a:rPr lang="en-US" sz="1250" b="1" dirty="0">
+                          <a:solidFill>
+                            <a:srgbClr val="FFFFFF"/>
+                          </a:solidFill>
+                          <a:latin typeface="Calibri" pitchFamily="34" charset="0"/>
+                          <a:ea typeface="Calibri" pitchFamily="34" charset="-122"/>
+                          <a:cs typeface="Calibri" pitchFamily="34" charset="-120"/>
+                        </a:rPr>
+                        <a:t>A3 + F5</a:t>
+                      </a:r>
+                      <a:endParaRPr lang="en-US" sz="1250" dirty="0">
+                        <a:latin typeface="Calibri" charset="0"/>
+                        <a:ea typeface="Calibri" charset="0"/>
+                        <a:cs typeface="Calibri" charset="0"/>
+                      </a:endParaRPr>
+                    </a:p>
+                  </a:txBody>
+                  <a:tcPr marL="91440" marR="91440" marT="45720" marB="45720" anchor="ctr">
+                    <a:lnL w="9525" cap="flat" cmpd="sng" algn="ctr">
+                      <a:solidFill>
+                        <a:srgbClr val="D9D9D9"/>
+                      </a:solidFill>
+                      <a:prstDash val="solid"/>
+                      <a:round/>
+                      <a:headEnd type="none" w="med" len="med"/>
+                      <a:tailEnd type="none" w="med" len="med"/>
+                    </a:lnL>
+                    <a:lnR w="9525" cap="flat" cmpd="sng" algn="ctr">
+                      <a:solidFill>
+                        <a:srgbClr val="D9D9D9"/>
+                      </a:solidFill>
+                      <a:prstDash val="solid"/>
+                      <a:round/>
+                      <a:headEnd type="none" w="med" len="med"/>
+                      <a:tailEnd type="none" w="med" len="med"/>
+                    </a:lnR>
+                    <a:lnT w="9525" cap="flat" cmpd="sng" algn="ctr">
+                      <a:solidFill>
+                        <a:srgbClr val="D9D9D9"/>
+                      </a:solidFill>
+                      <a:prstDash val="solid"/>
+                      <a:round/>
+                      <a:headEnd type="none" w="med" len="med"/>
+                      <a:tailEnd type="none" w="med" len="med"/>
+                    </a:lnT>
+                    <a:lnB w="9525" cap="flat" cmpd="sng" algn="ctr">
+                      <a:solidFill>
+                        <a:srgbClr val="D9D9D9"/>
+                      </a:solidFill>
+                      <a:prstDash val="solid"/>
+                      <a:round/>
+                      <a:headEnd type="none" w="med" len="med"/>
+                      <a:tailEnd type="none" w="med" len="med"/>
+                    </a:lnB>
+                    <a:solidFill>
+                      <a:srgbClr val="BE0000"/>
+                    </a:solidFill>
+                  </a:tcPr>
+                </a:tc>
+              </a:tr>
+              <a:tr h="384048">
+                <a:tc>
+                  <a:txBody>
+                    <a:bodyPr/>
+                    <a:lstStyle/>
+                    <a:p>
+                      <a:pPr algn="l" indent="0" marL="0">
+                        <a:buNone/>
+                      </a:pPr>
+                      <a:r>
+                        <a:rPr lang="en-US" sz="1200" b="1" dirty="0">
+                          <a:solidFill>
+                            <a:srgbClr val="2B2B2B"/>
+                          </a:solidFill>
+                          <a:latin typeface="Calibri" pitchFamily="34" charset="0"/>
+                          <a:ea typeface="Calibri" pitchFamily="34" charset="-122"/>
+                          <a:cs typeface="Calibri" pitchFamily="34" charset="-120"/>
+                        </a:rPr>
+                        <a:t>16 S-params (full array)</a:t>
+                      </a:r>
+                      <a:endParaRPr lang="en-US" sz="1200" dirty="0">
+                        <a:latin typeface="Calibri" charset="0"/>
+                        <a:ea typeface="Calibri" charset="0"/>
+                        <a:cs typeface="Calibri" charset="0"/>
+                      </a:endParaRPr>
+                    </a:p>
+                  </a:txBody>
+                  <a:tcPr marL="91440" marR="91440" marT="45720" marB="45720" anchor="ctr">
+                    <a:lnL w="9525" cap="flat" cmpd="sng" algn="ctr">
+                      <a:solidFill>
+                        <a:srgbClr val="D9D9D9"/>
+                      </a:solidFill>
+                      <a:prstDash val="solid"/>
+                      <a:round/>
+                      <a:headEnd type="none" w="med" len="med"/>
+                      <a:tailEnd type="none" w="med" len="med"/>
+                    </a:lnL>
+                    <a:lnR w="9525" cap="flat" cmpd="sng" algn="ctr">
+                      <a:solidFill>
+                        <a:srgbClr val="D9D9D9"/>
+                      </a:solidFill>
+                      <a:prstDash val="solid"/>
+                      <a:round/>
+                      <a:headEnd type="none" w="med" len="med"/>
+                      <a:tailEnd type="none" w="med" len="med"/>
+                    </a:lnR>
+                    <a:lnT w="9525" cap="flat" cmpd="sng" algn="ctr">
+                      <a:solidFill>
+                        <a:srgbClr val="D9D9D9"/>
+                      </a:solidFill>
+                      <a:prstDash val="solid"/>
+                      <a:round/>
+                      <a:headEnd type="none" w="med" len="med"/>
+                      <a:tailEnd type="none" w="med" len="med"/>
+                    </a:lnT>
+                    <a:lnB w="9525" cap="flat" cmpd="sng" algn="ctr">
+                      <a:solidFill>
+                        <a:srgbClr val="D9D9D9"/>
+                      </a:solidFill>
+                      <a:prstDash val="solid"/>
+                      <a:round/>
+                      <a:headEnd type="none" w="med" len="med"/>
+                      <a:tailEnd type="none" w="med" len="med"/>
+                    </a:lnB>
+                    <a:solidFill>
+                      <a:srgbClr val="FFFFFF"/>
+                    </a:solidFill>
+                  </a:tcPr>
+                </a:tc>
+                <a:tc>
+                  <a:txBody>
+                    <a:bodyPr/>
+                    <a:lstStyle/>
+                    <a:p>
+                      <a:pPr algn="ctr" indent="0" marL="0">
+                        <a:buNone/>
+                      </a:pPr>
+                      <a:r>
+                        <a:rPr lang="en-US" sz="1200" dirty="0">
+                          <a:solidFill>
+                            <a:srgbClr val="2B2B2B"/>
+                          </a:solidFill>
+                          <a:latin typeface="Calibri" pitchFamily="34" charset="0"/>
+                          <a:ea typeface="Calibri" pitchFamily="34" charset="-122"/>
+                          <a:cs typeface="Calibri" pitchFamily="34" charset="-120"/>
+                        </a:rPr>
+                        <a:t>never</a:t>
+                      </a:r>
+                      <a:endParaRPr lang="en-US" sz="1200" dirty="0">
+                        <a:latin typeface="Calibri" charset="0"/>
+                        <a:ea typeface="Calibri" charset="0"/>
+                        <a:cs typeface="Calibri" charset="0"/>
+                      </a:endParaRPr>
+                    </a:p>
+                  </a:txBody>
+                  <a:tcPr marL="91440" marR="91440" marT="45720" marB="45720" anchor="ctr">
+                    <a:lnL w="9525" cap="flat" cmpd="sng" algn="ctr">
+                      <a:solidFill>
+                        <a:srgbClr val="D9D9D9"/>
+                      </a:solidFill>
+                      <a:prstDash val="solid"/>
+                      <a:round/>
+                      <a:headEnd type="none" w="med" len="med"/>
+                      <a:tailEnd type="none" w="med" len="med"/>
+                    </a:lnL>
+                    <a:lnR w="9525" cap="flat" cmpd="sng" algn="ctr">
+                      <a:solidFill>
+                        <a:srgbClr val="D9D9D9"/>
+                      </a:solidFill>
+                      <a:prstDash val="solid"/>
+                      <a:round/>
+                      <a:headEnd type="none" w="med" len="med"/>
+                      <a:tailEnd type="none" w="med" len="med"/>
+                    </a:lnR>
+                    <a:lnT w="9525" cap="flat" cmpd="sng" algn="ctr">
+                      <a:solidFill>
+                        <a:srgbClr val="D9D9D9"/>
+                      </a:solidFill>
+                      <a:prstDash val="solid"/>
+                      <a:round/>
+                      <a:headEnd type="none" w="med" len="med"/>
+                      <a:tailEnd type="none" w="med" len="med"/>
+                    </a:lnT>
+                    <a:lnB w="9525" cap="flat" cmpd="sng" algn="ctr">
+                      <a:solidFill>
+                        <a:srgbClr val="D9D9D9"/>
+                      </a:solidFill>
+                      <a:prstDash val="solid"/>
+                      <a:round/>
+                      <a:headEnd type="none" w="med" len="med"/>
+                      <a:tailEnd type="none" w="med" len="med"/>
+                    </a:lnB>
+                    <a:solidFill>
+                      <a:srgbClr val="FFFFFF"/>
+                    </a:solidFill>
+                  </a:tcPr>
+                </a:tc>
+                <a:tc>
+                  <a:txBody>
+                    <a:bodyPr/>
+                    <a:lstStyle/>
+                    <a:p>
+                      <a:pPr algn="ctr" indent="0" marL="0">
+                        <a:buNone/>
+                      </a:pPr>
+                      <a:r>
+                        <a:rPr lang="en-US" sz="1200" dirty="0">
+                          <a:solidFill>
+                            <a:srgbClr val="2B2B2B"/>
+                          </a:solidFill>
+                          <a:latin typeface="Calibri" pitchFamily="34" charset="0"/>
+                          <a:ea typeface="Calibri" pitchFamily="34" charset="-122"/>
+                          <a:cs typeface="Calibri" pitchFamily="34" charset="-120"/>
+                        </a:rPr>
+                        <a:t>never</a:t>
+                      </a:r>
+                      <a:endParaRPr lang="en-US" sz="1200" dirty="0">
+                        <a:latin typeface="Calibri" charset="0"/>
+                        <a:ea typeface="Calibri" charset="0"/>
+                        <a:cs typeface="Calibri" charset="0"/>
+                      </a:endParaRPr>
+                    </a:p>
+                  </a:txBody>
+                  <a:tcPr marL="91440" marR="91440" marT="45720" marB="45720" anchor="ctr">
+                    <a:lnL w="9525" cap="flat" cmpd="sng" algn="ctr">
+                      <a:solidFill>
+                        <a:srgbClr val="D9D9D9"/>
+                      </a:solidFill>
+                      <a:prstDash val="solid"/>
+                      <a:round/>
+                      <a:headEnd type="none" w="med" len="med"/>
+                      <a:tailEnd type="none" w="med" len="med"/>
+                    </a:lnL>
+                    <a:lnR w="9525" cap="flat" cmpd="sng" algn="ctr">
+                      <a:solidFill>
+                        <a:srgbClr val="D9D9D9"/>
+                      </a:solidFill>
+                      <a:prstDash val="solid"/>
+                      <a:round/>
+                      <a:headEnd type="none" w="med" len="med"/>
+                      <a:tailEnd type="none" w="med" len="med"/>
+                    </a:lnR>
+                    <a:lnT w="9525" cap="flat" cmpd="sng" algn="ctr">
+                      <a:solidFill>
+                        <a:srgbClr val="D9D9D9"/>
+                      </a:solidFill>
+                      <a:prstDash val="solid"/>
+                      <a:round/>
+                      <a:headEnd type="none" w="med" len="med"/>
+                      <a:tailEnd type="none" w="med" len="med"/>
+                    </a:lnT>
+                    <a:lnB w="9525" cap="flat" cmpd="sng" algn="ctr">
+                      <a:solidFill>
+                        <a:srgbClr val="D9D9D9"/>
+                      </a:solidFill>
+                      <a:prstDash val="solid"/>
+                      <a:round/>
+                      <a:headEnd type="none" w="med" len="med"/>
+                      <a:tailEnd type="none" w="med" len="med"/>
+                    </a:lnB>
+                    <a:solidFill>
+                      <a:srgbClr val="FFFFFF"/>
+                    </a:solidFill>
+                  </a:tcPr>
+                </a:tc>
+                <a:tc>
+                  <a:txBody>
+                    <a:bodyPr/>
+                    <a:lstStyle/>
+                    <a:p>
+                      <a:pPr algn="ctr" indent="0" marL="0">
+                        <a:buNone/>
+                      </a:pPr>
+                      <a:r>
+                        <a:rPr lang="en-US" sz="1200" dirty="0">
+                          <a:solidFill>
+                            <a:srgbClr val="2B2B2B"/>
+                          </a:solidFill>
+                          <a:latin typeface="Calibri" pitchFamily="34" charset="0"/>
+                          <a:ea typeface="Calibri" pitchFamily="34" charset="-122"/>
+                          <a:cs typeface="Calibri" pitchFamily="34" charset="-120"/>
+                        </a:rPr>
+                        <a:t>never (floor 60)</a:t>
+                      </a:r>
+                      <a:endParaRPr lang="en-US" sz="1200" dirty="0">
+                        <a:latin typeface="Calibri" charset="0"/>
+                        <a:ea typeface="Calibri" charset="0"/>
+                        <a:cs typeface="Calibri" charset="0"/>
+                      </a:endParaRPr>
+                    </a:p>
+                  </a:txBody>
+                  <a:tcPr marL="91440" marR="91440" marT="45720" marB="45720" anchor="ctr">
+                    <a:lnL w="9525" cap="flat" cmpd="sng" algn="ctr">
+                      <a:solidFill>
+                        <a:srgbClr val="D9D9D9"/>
+                      </a:solidFill>
+                      <a:prstDash val="solid"/>
+                      <a:round/>
+                      <a:headEnd type="none" w="med" len="med"/>
+                      <a:tailEnd type="none" w="med" len="med"/>
+                    </a:lnL>
+                    <a:lnR w="9525" cap="flat" cmpd="sng" algn="ctr">
+                      <a:solidFill>
+                        <a:srgbClr val="D9D9D9"/>
+                      </a:solidFill>
+                      <a:prstDash val="solid"/>
+                      <a:round/>
+                      <a:headEnd type="none" w="med" len="med"/>
+                      <a:tailEnd type="none" w="med" len="med"/>
+                    </a:lnR>
+                    <a:lnT w="9525" cap="flat" cmpd="sng" algn="ctr">
+                      <a:solidFill>
+                        <a:srgbClr val="D9D9D9"/>
+                      </a:solidFill>
+                      <a:prstDash val="solid"/>
+                      <a:round/>
+                      <a:headEnd type="none" w="med" len="med"/>
+                      <a:tailEnd type="none" w="med" len="med"/>
+                    </a:lnT>
+                    <a:lnB w="9525" cap="flat" cmpd="sng" algn="ctr">
+                      <a:solidFill>
+                        <a:srgbClr val="D9D9D9"/>
+                      </a:solidFill>
+                      <a:prstDash val="solid"/>
+                      <a:round/>
+                      <a:headEnd type="none" w="med" len="med"/>
+                      <a:tailEnd type="none" w="med" len="med"/>
+                    </a:lnB>
+                    <a:solidFill>
+                      <a:srgbClr val="FFFFFF"/>
+                    </a:solidFill>
+                  </a:tcPr>
+                </a:tc>
+              </a:tr>
+              <a:tr h="384048">
+                <a:tc>
+                  <a:txBody>
+                    <a:bodyPr/>
+                    <a:lstStyle/>
+                    <a:p>
+                      <a:pPr algn="l" indent="0" marL="0">
+                        <a:buNone/>
+                      </a:pPr>
+                      <a:r>
+                        <a:rPr lang="en-US" sz="1200" b="1" dirty="0">
+                          <a:solidFill>
+                            <a:srgbClr val="2B2B2B"/>
+                          </a:solidFill>
+                          <a:latin typeface="Calibri" pitchFamily="34" charset="0"/>
+                          <a:ea typeface="Calibri" pitchFamily="34" charset="-122"/>
+                          <a:cs typeface="Calibri" pitchFamily="34" charset="-120"/>
+                        </a:rPr>
+                        <a:t>4 antennas, reflection only</a:t>
+                      </a:r>
+                      <a:endParaRPr lang="en-US" sz="1200" dirty="0">
+                        <a:latin typeface="Calibri" charset="0"/>
+                        <a:ea typeface="Calibri" charset="0"/>
+                        <a:cs typeface="Calibri" charset="0"/>
+                      </a:endParaRPr>
+                    </a:p>
+                  </a:txBody>
+                  <a:tcPr marL="91440" marR="91440" marT="45720" marB="45720" anchor="ctr">
+                    <a:lnL w="9525" cap="flat" cmpd="sng" algn="ctr">
+                      <a:solidFill>
+                        <a:srgbClr val="D9D9D9"/>
+                      </a:solidFill>
+                      <a:prstDash val="solid"/>
+                      <a:round/>
+                      <a:headEnd type="none" w="med" len="med"/>
+                      <a:tailEnd type="none" w="med" len="med"/>
+                    </a:lnL>
+                    <a:lnR w="9525" cap="flat" cmpd="sng" algn="ctr">
+                      <a:solidFill>
+                        <a:srgbClr val="D9D9D9"/>
+                      </a:solidFill>
+                      <a:prstDash val="solid"/>
+                      <a:round/>
+                      <a:headEnd type="none" w="med" len="med"/>
+                      <a:tailEnd type="none" w="med" len="med"/>
+                    </a:lnR>
+                    <a:lnT w="9525" cap="flat" cmpd="sng" algn="ctr">
+                      <a:solidFill>
+                        <a:srgbClr val="D9D9D9"/>
+                      </a:solidFill>
+                      <a:prstDash val="solid"/>
+                      <a:round/>
+                      <a:headEnd type="none" w="med" len="med"/>
+                      <a:tailEnd type="none" w="med" len="med"/>
+                    </a:lnT>
+                    <a:lnB w="9525" cap="flat" cmpd="sng" algn="ctr">
+                      <a:solidFill>
+                        <a:srgbClr val="D9D9D9"/>
+                      </a:solidFill>
+                      <a:prstDash val="solid"/>
+                      <a:round/>
+                      <a:headEnd type="none" w="med" len="med"/>
+                      <a:tailEnd type="none" w="med" len="med"/>
+                    </a:lnB>
+                    <a:solidFill>
+                      <a:srgbClr val="FBEDED"/>
+                    </a:solidFill>
+                  </a:tcPr>
+                </a:tc>
+                <a:tc>
+                  <a:txBody>
+                    <a:bodyPr/>
+                    <a:lstStyle/>
+                    <a:p>
+                      <a:pPr algn="ctr" indent="0" marL="0">
+                        <a:buNone/>
+                      </a:pPr>
+                      <a:r>
+                        <a:rPr lang="en-US" sz="1200" dirty="0">
+                          <a:solidFill>
+                            <a:srgbClr val="2B2B2B"/>
+                          </a:solidFill>
+                          <a:latin typeface="Calibri" pitchFamily="34" charset="0"/>
+                          <a:ea typeface="Calibri" pitchFamily="34" charset="-122"/>
+                          <a:cs typeface="Calibri" pitchFamily="34" charset="-120"/>
+                        </a:rPr>
+                        <a:t>never</a:t>
+                      </a:r>
+                      <a:endParaRPr lang="en-US" sz="1200" dirty="0">
+                        <a:latin typeface="Calibri" charset="0"/>
+                        <a:ea typeface="Calibri" charset="0"/>
+                        <a:cs typeface="Calibri" charset="0"/>
+                      </a:endParaRPr>
+                    </a:p>
+                  </a:txBody>
+                  <a:tcPr marL="91440" marR="91440" marT="45720" marB="45720" anchor="ctr">
+                    <a:lnL w="9525" cap="flat" cmpd="sng" algn="ctr">
+                      <a:solidFill>
+                        <a:srgbClr val="D9D9D9"/>
+                      </a:solidFill>
+                      <a:prstDash val="solid"/>
+                      <a:round/>
+                      <a:headEnd type="none" w="med" len="med"/>
+                      <a:tailEnd type="none" w="med" len="med"/>
+                    </a:lnL>
+                    <a:lnR w="9525" cap="flat" cmpd="sng" algn="ctr">
+                      <a:solidFill>
+                        <a:srgbClr val="D9D9D9"/>
+                      </a:solidFill>
+                      <a:prstDash val="solid"/>
+                      <a:round/>
+                      <a:headEnd type="none" w="med" len="med"/>
+                      <a:tailEnd type="none" w="med" len="med"/>
+                    </a:lnR>
+                    <a:lnT w="9525" cap="flat" cmpd="sng" algn="ctr">
+                      <a:solidFill>
+                        <a:srgbClr val="D9D9D9"/>
+                      </a:solidFill>
+                      <a:prstDash val="solid"/>
+                      <a:round/>
+                      <a:headEnd type="none" w="med" len="med"/>
+                      <a:tailEnd type="none" w="med" len="med"/>
+                    </a:lnT>
+                    <a:lnB w="9525" cap="flat" cmpd="sng" algn="ctr">
+                      <a:solidFill>
+                        <a:srgbClr val="D9D9D9"/>
+                      </a:solidFill>
+                      <a:prstDash val="solid"/>
+                      <a:round/>
+                      <a:headEnd type="none" w="med" len="med"/>
+                      <a:tailEnd type="none" w="med" len="med"/>
+                    </a:lnB>
+                    <a:solidFill>
+                      <a:srgbClr val="FBEDED"/>
+                    </a:solidFill>
+                  </a:tcPr>
+                </a:tc>
+                <a:tc>
+                  <a:txBody>
+                    <a:bodyPr/>
+                    <a:lstStyle/>
+                    <a:p>
+                      <a:pPr algn="ctr" indent="0" marL="0">
+                        <a:buNone/>
+                      </a:pPr>
+                      <a:r>
+                        <a:rPr lang="en-US" sz="1200" dirty="0">
+                          <a:solidFill>
+                            <a:srgbClr val="2B2B2B"/>
+                          </a:solidFill>
+                          <a:latin typeface="Calibri" pitchFamily="34" charset="0"/>
+                          <a:ea typeface="Calibri" pitchFamily="34" charset="-122"/>
+                          <a:cs typeface="Calibri" pitchFamily="34" charset="-120"/>
+                        </a:rPr>
+                        <a:t>never</a:t>
+                      </a:r>
+                      <a:endParaRPr lang="en-US" sz="1200" dirty="0">
+                        <a:latin typeface="Calibri" charset="0"/>
+                        <a:ea typeface="Calibri" charset="0"/>
+                        <a:cs typeface="Calibri" charset="0"/>
+                      </a:endParaRPr>
+                    </a:p>
+                  </a:txBody>
+                  <a:tcPr marL="91440" marR="91440" marT="45720" marB="45720" anchor="ctr">
+                    <a:lnL w="9525" cap="flat" cmpd="sng" algn="ctr">
+                      <a:solidFill>
+                        <a:srgbClr val="D9D9D9"/>
+                      </a:solidFill>
+                      <a:prstDash val="solid"/>
+                      <a:round/>
+                      <a:headEnd type="none" w="med" len="med"/>
+                      <a:tailEnd type="none" w="med" len="med"/>
+                    </a:lnL>
+                    <a:lnR w="9525" cap="flat" cmpd="sng" algn="ctr">
+                      <a:solidFill>
+                        <a:srgbClr val="D9D9D9"/>
+                      </a:solidFill>
+                      <a:prstDash val="solid"/>
+                      <a:round/>
+                      <a:headEnd type="none" w="med" len="med"/>
+                      <a:tailEnd type="none" w="med" len="med"/>
+                    </a:lnR>
+                    <a:lnT w="9525" cap="flat" cmpd="sng" algn="ctr">
+                      <a:solidFill>
+                        <a:srgbClr val="D9D9D9"/>
+                      </a:solidFill>
+                      <a:prstDash val="solid"/>
+                      <a:round/>
+                      <a:headEnd type="none" w="med" len="med"/>
+                      <a:tailEnd type="none" w="med" len="med"/>
+                    </a:lnT>
+                    <a:lnB w="9525" cap="flat" cmpd="sng" algn="ctr">
+                      <a:solidFill>
+                        <a:srgbClr val="D9D9D9"/>
+                      </a:solidFill>
+                      <a:prstDash val="solid"/>
+                      <a:round/>
+                      <a:headEnd type="none" w="med" len="med"/>
+                      <a:tailEnd type="none" w="med" len="med"/>
+                    </a:lnB>
+                    <a:solidFill>
+                      <a:srgbClr val="FBEDED"/>
+                    </a:solidFill>
+                  </a:tcPr>
+                </a:tc>
+                <a:tc>
+                  <a:txBody>
+                    <a:bodyPr/>
+                    <a:lstStyle/>
+                    <a:p>
+                      <a:pPr algn="ctr" indent="0" marL="0">
+                        <a:buNone/>
+                      </a:pPr>
+                      <a:r>
+                        <a:rPr lang="en-US" sz="1200" b="1" dirty="0">
+                          <a:solidFill>
+                            <a:srgbClr val="BE0000"/>
+                          </a:solidFill>
+                          <a:latin typeface="Calibri" pitchFamily="34" charset="0"/>
+                          <a:ea typeface="Calibri" pitchFamily="34" charset="-122"/>
+                          <a:cs typeface="Calibri" pitchFamily="34" charset="-120"/>
+                        </a:rPr>
+                        <a:t>0.1 GHz (47%)</a:t>
+                      </a:r>
+                      <a:endParaRPr lang="en-US" sz="1200" dirty="0">
+                        <a:latin typeface="Calibri" charset="0"/>
+                        <a:ea typeface="Calibri" charset="0"/>
+                        <a:cs typeface="Calibri" charset="0"/>
+                      </a:endParaRPr>
+                    </a:p>
+                  </a:txBody>
+                  <a:tcPr marL="91440" marR="91440" marT="45720" marB="45720" anchor="ctr">
+                    <a:lnL w="9525" cap="flat" cmpd="sng" algn="ctr">
+                      <a:solidFill>
+                        <a:srgbClr val="D9D9D9"/>
+                      </a:solidFill>
+                      <a:prstDash val="solid"/>
+                      <a:round/>
+                      <a:headEnd type="none" w="med" len="med"/>
+                      <a:tailEnd type="none" w="med" len="med"/>
+                    </a:lnL>
+                    <a:lnR w="9525" cap="flat" cmpd="sng" algn="ctr">
+                      <a:solidFill>
+                        <a:srgbClr val="D9D9D9"/>
+                      </a:solidFill>
+                      <a:prstDash val="solid"/>
+                      <a:round/>
+                      <a:headEnd type="none" w="med" len="med"/>
+                      <a:tailEnd type="none" w="med" len="med"/>
+                    </a:lnR>
+                    <a:lnT w="9525" cap="flat" cmpd="sng" algn="ctr">
+                      <a:solidFill>
+                        <a:srgbClr val="D9D9D9"/>
+                      </a:solidFill>
+                      <a:prstDash val="solid"/>
+                      <a:round/>
+                      <a:headEnd type="none" w="med" len="med"/>
+                      <a:tailEnd type="none" w="med" len="med"/>
+                    </a:lnT>
+                    <a:lnB w="9525" cap="flat" cmpd="sng" algn="ctr">
+                      <a:solidFill>
+                        <a:srgbClr val="D9D9D9"/>
+                      </a:solidFill>
+                      <a:prstDash val="solid"/>
+                      <a:round/>
+                      <a:headEnd type="none" w="med" len="med"/>
+                      <a:tailEnd type="none" w="med" len="med"/>
+                    </a:lnB>
+                    <a:solidFill>
+                      <a:srgbClr val="FBEDED"/>
+                    </a:solidFill>
+                  </a:tcPr>
+                </a:tc>
+              </a:tr>
+              <a:tr h="384048">
+                <a:tc>
+                  <a:txBody>
+                    <a:bodyPr/>
+                    <a:lstStyle/>
+                    <a:p>
+                      <a:pPr algn="l" indent="0" marL="0">
+                        <a:buNone/>
+                      </a:pPr>
+                      <a:r>
+                        <a:rPr lang="en-US" sz="1200" b="1" dirty="0">
+                          <a:solidFill>
+                            <a:srgbClr val="2B2B2B"/>
+                          </a:solidFill>
+                          <a:latin typeface="Calibri" pitchFamily="34" charset="0"/>
+                          <a:ea typeface="Calibri" pitchFamily="34" charset="-122"/>
+                          <a:cs typeface="Calibri" pitchFamily="34" charset="-120"/>
+                        </a:rPr>
+                        <a:t>2 antennas (1 &amp; 3), full S</a:t>
+                      </a:r>
+                      <a:endParaRPr lang="en-US" sz="1200" dirty="0">
+                        <a:latin typeface="Calibri" charset="0"/>
+                        <a:ea typeface="Calibri" charset="0"/>
+                        <a:cs typeface="Calibri" charset="0"/>
+                      </a:endParaRPr>
+                    </a:p>
+                  </a:txBody>
+                  <a:tcPr marL="91440" marR="91440" marT="45720" marB="45720" anchor="ctr">
+                    <a:lnL w="9525" cap="flat" cmpd="sng" algn="ctr">
+                      <a:solidFill>
+                        <a:srgbClr val="D9D9D9"/>
+                      </a:solidFill>
+                      <a:prstDash val="solid"/>
+                      <a:round/>
+                      <a:headEnd type="none" w="med" len="med"/>
+                      <a:tailEnd type="none" w="med" len="med"/>
+                    </a:lnL>
+                    <a:lnR w="9525" cap="flat" cmpd="sng" algn="ctr">
+                      <a:solidFill>
+                        <a:srgbClr val="D9D9D9"/>
+                      </a:solidFill>
+                      <a:prstDash val="solid"/>
+                      <a:round/>
+                      <a:headEnd type="none" w="med" len="med"/>
+                      <a:tailEnd type="none" w="med" len="med"/>
+                    </a:lnR>
+                    <a:lnT w="9525" cap="flat" cmpd="sng" algn="ctr">
+                      <a:solidFill>
+                        <a:srgbClr val="D9D9D9"/>
+                      </a:solidFill>
+                      <a:prstDash val="solid"/>
+                      <a:round/>
+                      <a:headEnd type="none" w="med" len="med"/>
+                      <a:tailEnd type="none" w="med" len="med"/>
+                    </a:lnT>
+                    <a:lnB w="9525" cap="flat" cmpd="sng" algn="ctr">
+                      <a:solidFill>
+                        <a:srgbClr val="D9D9D9"/>
+                      </a:solidFill>
+                      <a:prstDash val="solid"/>
+                      <a:round/>
+                      <a:headEnd type="none" w="med" len="med"/>
+                      <a:tailEnd type="none" w="med" len="med"/>
+                    </a:lnB>
+                    <a:solidFill>
+                      <a:srgbClr val="FFFFFF"/>
+                    </a:solidFill>
+                  </a:tcPr>
+                </a:tc>
+                <a:tc>
+                  <a:txBody>
+                    <a:bodyPr/>
+                    <a:lstStyle/>
+                    <a:p>
+                      <a:pPr algn="ctr" indent="0" marL="0">
+                        <a:buNone/>
+                      </a:pPr>
+                      <a:r>
+                        <a:rPr lang="en-US" sz="1200" dirty="0">
+                          <a:solidFill>
+                            <a:srgbClr val="2B2B2B"/>
+                          </a:solidFill>
+                          <a:latin typeface="Calibri" pitchFamily="34" charset="0"/>
+                          <a:ea typeface="Calibri" pitchFamily="34" charset="-122"/>
+                          <a:cs typeface="Calibri" pitchFamily="34" charset="-120"/>
+                        </a:rPr>
+                        <a:t>never</a:t>
+                      </a:r>
+                      <a:endParaRPr lang="en-US" sz="1200" dirty="0">
+                        <a:latin typeface="Calibri" charset="0"/>
+                        <a:ea typeface="Calibri" charset="0"/>
+                        <a:cs typeface="Calibri" charset="0"/>
+                      </a:endParaRPr>
+                    </a:p>
+                  </a:txBody>
+                  <a:tcPr marL="91440" marR="91440" marT="45720" marB="45720" anchor="ctr">
+                    <a:lnL w="9525" cap="flat" cmpd="sng" algn="ctr">
+                      <a:solidFill>
+                        <a:srgbClr val="D9D9D9"/>
+                      </a:solidFill>
+                      <a:prstDash val="solid"/>
+                      <a:round/>
+                      <a:headEnd type="none" w="med" len="med"/>
+                      <a:tailEnd type="none" w="med" len="med"/>
+                    </a:lnL>
+                    <a:lnR w="9525" cap="flat" cmpd="sng" algn="ctr">
+                      <a:solidFill>
+                        <a:srgbClr val="D9D9D9"/>
+                      </a:solidFill>
+                      <a:prstDash val="solid"/>
+                      <a:round/>
+                      <a:headEnd type="none" w="med" len="med"/>
+                      <a:tailEnd type="none" w="med" len="med"/>
+                    </a:lnR>
+                    <a:lnT w="9525" cap="flat" cmpd="sng" algn="ctr">
+                      <a:solidFill>
+                        <a:srgbClr val="D9D9D9"/>
+                      </a:solidFill>
+                      <a:prstDash val="solid"/>
+                      <a:round/>
+                      <a:headEnd type="none" w="med" len="med"/>
+                      <a:tailEnd type="none" w="med" len="med"/>
+                    </a:lnT>
+                    <a:lnB w="9525" cap="flat" cmpd="sng" algn="ctr">
+                      <a:solidFill>
+                        <a:srgbClr val="D9D9D9"/>
+                      </a:solidFill>
+                      <a:prstDash val="solid"/>
+                      <a:round/>
+                      <a:headEnd type="none" w="med" len="med"/>
+                      <a:tailEnd type="none" w="med" len="med"/>
+                    </a:lnB>
+                    <a:solidFill>
+                      <a:srgbClr val="FFFFFF"/>
+                    </a:solidFill>
+                  </a:tcPr>
+                </a:tc>
+                <a:tc>
+                  <a:txBody>
+                    <a:bodyPr/>
+                    <a:lstStyle/>
+                    <a:p>
+                      <a:pPr algn="ctr" indent="0" marL="0">
+                        <a:buNone/>
+                      </a:pPr>
+                      <a:r>
+                        <a:rPr lang="en-US" sz="1200" dirty="0">
+                          <a:solidFill>
+                            <a:srgbClr val="2B2B2B"/>
+                          </a:solidFill>
+                          <a:latin typeface="Calibri" pitchFamily="34" charset="0"/>
+                          <a:ea typeface="Calibri" pitchFamily="34" charset="-122"/>
+                          <a:cs typeface="Calibri" pitchFamily="34" charset="-120"/>
+                        </a:rPr>
+                        <a:t>never</a:t>
+                      </a:r>
+                      <a:endParaRPr lang="en-US" sz="1200" dirty="0">
+                        <a:latin typeface="Calibri" charset="0"/>
+                        <a:ea typeface="Calibri" charset="0"/>
+                        <a:cs typeface="Calibri" charset="0"/>
+                      </a:endParaRPr>
+                    </a:p>
+                  </a:txBody>
+                  <a:tcPr marL="91440" marR="91440" marT="45720" marB="45720" anchor="ctr">
+                    <a:lnL w="9525" cap="flat" cmpd="sng" algn="ctr">
+                      <a:solidFill>
+                        <a:srgbClr val="D9D9D9"/>
+                      </a:solidFill>
+                      <a:prstDash val="solid"/>
+                      <a:round/>
+                      <a:headEnd type="none" w="med" len="med"/>
+                      <a:tailEnd type="none" w="med" len="med"/>
+                    </a:lnL>
+                    <a:lnR w="9525" cap="flat" cmpd="sng" algn="ctr">
+                      <a:solidFill>
+                        <a:srgbClr val="D9D9D9"/>
+                      </a:solidFill>
+                      <a:prstDash val="solid"/>
+                      <a:round/>
+                      <a:headEnd type="none" w="med" len="med"/>
+                      <a:tailEnd type="none" w="med" len="med"/>
+                    </a:lnR>
+                    <a:lnT w="9525" cap="flat" cmpd="sng" algn="ctr">
+                      <a:solidFill>
+                        <a:srgbClr val="D9D9D9"/>
+                      </a:solidFill>
+                      <a:prstDash val="solid"/>
+                      <a:round/>
+                      <a:headEnd type="none" w="med" len="med"/>
+                      <a:tailEnd type="none" w="med" len="med"/>
+                    </a:lnT>
+                    <a:lnB w="9525" cap="flat" cmpd="sng" algn="ctr">
+                      <a:solidFill>
+                        <a:srgbClr val="D9D9D9"/>
+                      </a:solidFill>
+                      <a:prstDash val="solid"/>
+                      <a:round/>
+                      <a:headEnd type="none" w="med" len="med"/>
+                      <a:tailEnd type="none" w="med" len="med"/>
+                    </a:lnB>
+                    <a:solidFill>
+                      <a:srgbClr val="FFFFFF"/>
+                    </a:solidFill>
+                  </a:tcPr>
+                </a:tc>
+                <a:tc>
+                  <a:txBody>
+                    <a:bodyPr/>
+                    <a:lstStyle/>
+                    <a:p>
+                      <a:pPr algn="ctr" indent="0" marL="0">
+                        <a:buNone/>
+                      </a:pPr>
+                      <a:r>
+                        <a:rPr lang="en-US" sz="1200" b="1" dirty="0">
+                          <a:solidFill>
+                            <a:srgbClr val="BE0000"/>
+                          </a:solidFill>
+                          <a:latin typeface="Calibri" pitchFamily="34" charset="0"/>
+                          <a:ea typeface="Calibri" pitchFamily="34" charset="-122"/>
+                          <a:cs typeface="Calibri" pitchFamily="34" charset="-120"/>
+                        </a:rPr>
+                        <a:t>0.5 GHz (35%)</a:t>
+                      </a:r>
+                      <a:endParaRPr lang="en-US" sz="1200" dirty="0">
+                        <a:latin typeface="Calibri" charset="0"/>
+                        <a:ea typeface="Calibri" charset="0"/>
+                        <a:cs typeface="Calibri" charset="0"/>
+                      </a:endParaRPr>
+                    </a:p>
+                  </a:txBody>
+                  <a:tcPr marL="91440" marR="91440" marT="45720" marB="45720" anchor="ctr">
+                    <a:lnL w="9525" cap="flat" cmpd="sng" algn="ctr">
+                      <a:solidFill>
+                        <a:srgbClr val="D9D9D9"/>
+                      </a:solidFill>
+                      <a:prstDash val="solid"/>
+                      <a:round/>
+                      <a:headEnd type="none" w="med" len="med"/>
+                      <a:tailEnd type="none" w="med" len="med"/>
+                    </a:lnL>
+                    <a:lnR w="9525" cap="flat" cmpd="sng" algn="ctr">
+                      <a:solidFill>
+                        <a:srgbClr val="D9D9D9"/>
+                      </a:solidFill>
+                      <a:prstDash val="solid"/>
+                      <a:round/>
+                      <a:headEnd type="none" w="med" len="med"/>
+                      <a:tailEnd type="none" w="med" len="med"/>
+                    </a:lnR>
+                    <a:lnT w="9525" cap="flat" cmpd="sng" algn="ctr">
+                      <a:solidFill>
+                        <a:srgbClr val="D9D9D9"/>
+                      </a:solidFill>
+                      <a:prstDash val="solid"/>
+                      <a:round/>
+                      <a:headEnd type="none" w="med" len="med"/>
+                      <a:tailEnd type="none" w="med" len="med"/>
+                    </a:lnT>
+                    <a:lnB w="9525" cap="flat" cmpd="sng" algn="ctr">
+                      <a:solidFill>
+                        <a:srgbClr val="D9D9D9"/>
+                      </a:solidFill>
+                      <a:prstDash val="solid"/>
+                      <a:round/>
+                      <a:headEnd type="none" w="med" len="med"/>
+                      <a:tailEnd type="none" w="med" len="med"/>
+                    </a:lnB>
+                    <a:solidFill>
+                      <a:srgbClr val="FFFFFF"/>
+                    </a:solidFill>
+                  </a:tcPr>
+                </a:tc>
+              </a:tr>
+              <a:tr h="384048">
+                <a:tc>
+                  <a:txBody>
+                    <a:bodyPr/>
+                    <a:lstStyle/>
+                    <a:p>
+                      <a:pPr algn="l" indent="0" marL="0">
+                        <a:buNone/>
+                      </a:pPr>
+                      <a:r>
+                        <a:rPr lang="en-US" sz="1200" b="1" dirty="0">
+                          <a:solidFill>
+                            <a:srgbClr val="2B2B2B"/>
+                          </a:solidFill>
+                          <a:latin typeface="Calibri" pitchFamily="34" charset="0"/>
+                          <a:ea typeface="Calibri" pitchFamily="34" charset="-122"/>
+                          <a:cs typeface="Calibri" pitchFamily="34" charset="-120"/>
+                        </a:rPr>
+                        <a:t>2 antennas (1 &amp; 3), reflection only</a:t>
+                      </a:r>
+                      <a:endParaRPr lang="en-US" sz="1200" dirty="0">
+                        <a:latin typeface="Calibri" charset="0"/>
+                        <a:ea typeface="Calibri" charset="0"/>
+                        <a:cs typeface="Calibri" charset="0"/>
+                      </a:endParaRPr>
+                    </a:p>
+                  </a:txBody>
+                  <a:tcPr marL="91440" marR="91440" marT="45720" marB="45720" anchor="ctr">
+                    <a:lnL w="9525" cap="flat" cmpd="sng" algn="ctr">
+                      <a:solidFill>
+                        <a:srgbClr val="D9D9D9"/>
+                      </a:solidFill>
+                      <a:prstDash val="solid"/>
+                      <a:round/>
+                      <a:headEnd type="none" w="med" len="med"/>
+                      <a:tailEnd type="none" w="med" len="med"/>
+                    </a:lnL>
+                    <a:lnR w="9525" cap="flat" cmpd="sng" algn="ctr">
+                      <a:solidFill>
+                        <a:srgbClr val="D9D9D9"/>
+                      </a:solidFill>
+                      <a:prstDash val="solid"/>
+                      <a:round/>
+                      <a:headEnd type="none" w="med" len="med"/>
+                      <a:tailEnd type="none" w="med" len="med"/>
+                    </a:lnR>
+                    <a:lnT w="9525" cap="flat" cmpd="sng" algn="ctr">
+                      <a:solidFill>
+                        <a:srgbClr val="D9D9D9"/>
+                      </a:solidFill>
+                      <a:prstDash val="solid"/>
+                      <a:round/>
+                      <a:headEnd type="none" w="med" len="med"/>
+                      <a:tailEnd type="none" w="med" len="med"/>
+                    </a:lnT>
+                    <a:lnB w="9525" cap="flat" cmpd="sng" algn="ctr">
+                      <a:solidFill>
+                        <a:srgbClr val="D9D9D9"/>
+                      </a:solidFill>
+                      <a:prstDash val="solid"/>
+                      <a:round/>
+                      <a:headEnd type="none" w="med" len="med"/>
+                      <a:tailEnd type="none" w="med" len="med"/>
+                    </a:lnB>
+                    <a:solidFill>
+                      <a:srgbClr val="FBEDED"/>
+                    </a:solidFill>
+                  </a:tcPr>
+                </a:tc>
+                <a:tc>
+                  <a:txBody>
+                    <a:bodyPr/>
+                    <a:lstStyle/>
+                    <a:p>
+                      <a:pPr algn="ctr" indent="0" marL="0">
+                        <a:buNone/>
+                      </a:pPr>
+                      <a:r>
+                        <a:rPr lang="en-US" sz="1200" dirty="0">
+                          <a:solidFill>
+                            <a:srgbClr val="2B2B2B"/>
+                          </a:solidFill>
+                          <a:latin typeface="Calibri" pitchFamily="34" charset="0"/>
+                          <a:ea typeface="Calibri" pitchFamily="34" charset="-122"/>
+                          <a:cs typeface="Calibri" pitchFamily="34" charset="-120"/>
+                        </a:rPr>
+                        <a:t>never</a:t>
+                      </a:r>
+                      <a:endParaRPr lang="en-US" sz="1200" dirty="0">
+                        <a:latin typeface="Calibri" charset="0"/>
+                        <a:ea typeface="Calibri" charset="0"/>
+                        <a:cs typeface="Calibri" charset="0"/>
+                      </a:endParaRPr>
+                    </a:p>
+                  </a:txBody>
+                  <a:tcPr marL="91440" marR="91440" marT="45720" marB="45720" anchor="ctr">
+                    <a:lnL w="9525" cap="flat" cmpd="sng" algn="ctr">
+                      <a:solidFill>
+                        <a:srgbClr val="D9D9D9"/>
+                      </a:solidFill>
+                      <a:prstDash val="solid"/>
+                      <a:round/>
+                      <a:headEnd type="none" w="med" len="med"/>
+                      <a:tailEnd type="none" w="med" len="med"/>
+                    </a:lnL>
+                    <a:lnR w="9525" cap="flat" cmpd="sng" algn="ctr">
+                      <a:solidFill>
+                        <a:srgbClr val="D9D9D9"/>
+                      </a:solidFill>
+                      <a:prstDash val="solid"/>
+                      <a:round/>
+                      <a:headEnd type="none" w="med" len="med"/>
+                      <a:tailEnd type="none" w="med" len="med"/>
+                    </a:lnR>
+                    <a:lnT w="9525" cap="flat" cmpd="sng" algn="ctr">
+                      <a:solidFill>
+                        <a:srgbClr val="D9D9D9"/>
+                      </a:solidFill>
+                      <a:prstDash val="solid"/>
+                      <a:round/>
+                      <a:headEnd type="none" w="med" len="med"/>
+                      <a:tailEnd type="none" w="med" len="med"/>
+                    </a:lnT>
+                    <a:lnB w="9525" cap="flat" cmpd="sng" algn="ctr">
+                      <a:solidFill>
+                        <a:srgbClr val="D9D9D9"/>
+                      </a:solidFill>
+                      <a:prstDash val="solid"/>
+                      <a:round/>
+                      <a:headEnd type="none" w="med" len="med"/>
+                      <a:tailEnd type="none" w="med" len="med"/>
+                    </a:lnB>
+                    <a:solidFill>
+                      <a:srgbClr val="FBEDED"/>
+                    </a:solidFill>
+                  </a:tcPr>
+                </a:tc>
+                <a:tc>
+                  <a:txBody>
+                    <a:bodyPr/>
+                    <a:lstStyle/>
+                    <a:p>
+                      <a:pPr algn="ctr" indent="0" marL="0">
+                        <a:buNone/>
+                      </a:pPr>
+                      <a:r>
+                        <a:rPr lang="en-US" sz="1200" dirty="0">
+                          <a:solidFill>
+                            <a:srgbClr val="2B2B2B"/>
+                          </a:solidFill>
+                          <a:latin typeface="Calibri" pitchFamily="34" charset="0"/>
+                          <a:ea typeface="Calibri" pitchFamily="34" charset="-122"/>
+                          <a:cs typeface="Calibri" pitchFamily="34" charset="-120"/>
+                        </a:rPr>
+                        <a:t>never</a:t>
+                      </a:r>
+                      <a:endParaRPr lang="en-US" sz="1200" dirty="0">
+                        <a:latin typeface="Calibri" charset="0"/>
+                        <a:ea typeface="Calibri" charset="0"/>
+                        <a:cs typeface="Calibri" charset="0"/>
+                      </a:endParaRPr>
+                    </a:p>
+                  </a:txBody>
+                  <a:tcPr marL="91440" marR="91440" marT="45720" marB="45720" anchor="ctr">
+                    <a:lnL w="9525" cap="flat" cmpd="sng" algn="ctr">
+                      <a:solidFill>
+                        <a:srgbClr val="D9D9D9"/>
+                      </a:solidFill>
+                      <a:prstDash val="solid"/>
+                      <a:round/>
+                      <a:headEnd type="none" w="med" len="med"/>
+                      <a:tailEnd type="none" w="med" len="med"/>
+                    </a:lnL>
+                    <a:lnR w="9525" cap="flat" cmpd="sng" algn="ctr">
+                      <a:solidFill>
+                        <a:srgbClr val="D9D9D9"/>
+                      </a:solidFill>
+                      <a:prstDash val="solid"/>
+                      <a:round/>
+                      <a:headEnd type="none" w="med" len="med"/>
+                      <a:tailEnd type="none" w="med" len="med"/>
+                    </a:lnR>
+                    <a:lnT w="9525" cap="flat" cmpd="sng" algn="ctr">
+                      <a:solidFill>
+                        <a:srgbClr val="D9D9D9"/>
+                      </a:solidFill>
+                      <a:prstDash val="solid"/>
+                      <a:round/>
+                      <a:headEnd type="none" w="med" len="med"/>
+                      <a:tailEnd type="none" w="med" len="med"/>
+                    </a:lnT>
+                    <a:lnB w="9525" cap="flat" cmpd="sng" algn="ctr">
+                      <a:solidFill>
+                        <a:srgbClr val="D9D9D9"/>
+                      </a:solidFill>
+                      <a:prstDash val="solid"/>
+                      <a:round/>
+                      <a:headEnd type="none" w="med" len="med"/>
+                      <a:tailEnd type="none" w="med" len="med"/>
+                    </a:lnB>
+                    <a:solidFill>
+                      <a:srgbClr val="FBEDED"/>
+                    </a:solidFill>
+                  </a:tcPr>
+                </a:tc>
+                <a:tc>
+                  <a:txBody>
+                    <a:bodyPr/>
+                    <a:lstStyle/>
+                    <a:p>
+                      <a:pPr algn="ctr" indent="0" marL="0">
+                        <a:buNone/>
+                      </a:pPr>
+                      <a:r>
+                        <a:rPr lang="en-US" sz="1200" b="1" dirty="0">
+                          <a:solidFill>
+                            <a:srgbClr val="BE0000"/>
+                          </a:solidFill>
+                          <a:latin typeface="Calibri" pitchFamily="34" charset="0"/>
+                          <a:ea typeface="Calibri" pitchFamily="34" charset="-122"/>
+                          <a:cs typeface="Calibri" pitchFamily="34" charset="-120"/>
+                        </a:rPr>
+                        <a:t>1 GHz (45%)</a:t>
+                      </a:r>
+                      <a:endParaRPr lang="en-US" sz="1200" dirty="0">
+                        <a:latin typeface="Calibri" charset="0"/>
+                        <a:ea typeface="Calibri" charset="0"/>
+                        <a:cs typeface="Calibri" charset="0"/>
+                      </a:endParaRPr>
+                    </a:p>
+                  </a:txBody>
+                  <a:tcPr marL="91440" marR="91440" marT="45720" marB="45720" anchor="ctr">
+                    <a:lnL w="9525" cap="flat" cmpd="sng" algn="ctr">
+                      <a:solidFill>
+                        <a:srgbClr val="D9D9D9"/>
+                      </a:solidFill>
+                      <a:prstDash val="solid"/>
+                      <a:round/>
+                      <a:headEnd type="none" w="med" len="med"/>
+                      <a:tailEnd type="none" w="med" len="med"/>
+                    </a:lnL>
+                    <a:lnR w="9525" cap="flat" cmpd="sng" algn="ctr">
+                      <a:solidFill>
+                        <a:srgbClr val="D9D9D9"/>
+                      </a:solidFill>
+                      <a:prstDash val="solid"/>
+                      <a:round/>
+                      <a:headEnd type="none" w="med" len="med"/>
+                      <a:tailEnd type="none" w="med" len="med"/>
+                    </a:lnR>
+                    <a:lnT w="9525" cap="flat" cmpd="sng" algn="ctr">
+                      <a:solidFill>
+                        <a:srgbClr val="D9D9D9"/>
+                      </a:solidFill>
+                      <a:prstDash val="solid"/>
+                      <a:round/>
+                      <a:headEnd type="none" w="med" len="med"/>
+                      <a:tailEnd type="none" w="med" len="med"/>
+                    </a:lnT>
+                    <a:lnB w="9525" cap="flat" cmpd="sng" algn="ctr">
+                      <a:solidFill>
+                        <a:srgbClr val="D9D9D9"/>
+                      </a:solidFill>
+                      <a:prstDash val="solid"/>
+                      <a:round/>
+                      <a:headEnd type="none" w="med" len="med"/>
+                      <a:tailEnd type="none" w="med" len="med"/>
+                    </a:lnB>
+                    <a:solidFill>
+                      <a:srgbClr val="FBEDED"/>
+                    </a:solidFill>
+                  </a:tcPr>
+                </a:tc>
+              </a:tr>
+              <a:tr h="384048">
+                <a:tc>
+                  <a:txBody>
+                    <a:bodyPr/>
+                    <a:lstStyle/>
+                    <a:p>
+                      <a:pPr algn="l" indent="0" marL="0">
+                        <a:buNone/>
+                      </a:pPr>
+                      <a:r>
+                        <a:rPr lang="en-US" sz="1200" b="1" dirty="0">
+                          <a:solidFill>
+                            <a:srgbClr val="2B2B2B"/>
+                          </a:solidFill>
+                          <a:latin typeface="Calibri" pitchFamily="34" charset="0"/>
+                          <a:ea typeface="Calibri" pitchFamily="34" charset="-122"/>
+                          <a:cs typeface="Calibri" pitchFamily="34" charset="-120"/>
+                        </a:rPr>
+                        <a:t>1 antenna (S11 only)</a:t>
+                      </a:r>
+                      <a:endParaRPr lang="en-US" sz="1200" dirty="0">
+                        <a:latin typeface="Calibri" charset="0"/>
+                        <a:ea typeface="Calibri" charset="0"/>
+                        <a:cs typeface="Calibri" charset="0"/>
+                      </a:endParaRPr>
+                    </a:p>
+                  </a:txBody>
+                  <a:tcPr marL="91440" marR="91440" marT="45720" marB="45720" anchor="ctr">
+                    <a:lnL w="9525" cap="flat" cmpd="sng" algn="ctr">
+                      <a:solidFill>
+                        <a:srgbClr val="D9D9D9"/>
+                      </a:solidFill>
+                      <a:prstDash val="solid"/>
+                      <a:round/>
+                      <a:headEnd type="none" w="med" len="med"/>
+                      <a:tailEnd type="none" w="med" len="med"/>
+                    </a:lnL>
+                    <a:lnR w="9525" cap="flat" cmpd="sng" algn="ctr">
+                      <a:solidFill>
+                        <a:srgbClr val="D9D9D9"/>
+                      </a:solidFill>
+                      <a:prstDash val="solid"/>
+                      <a:round/>
+                      <a:headEnd type="none" w="med" len="med"/>
+                      <a:tailEnd type="none" w="med" len="med"/>
+                    </a:lnR>
+                    <a:lnT w="9525" cap="flat" cmpd="sng" algn="ctr">
+                      <a:solidFill>
+                        <a:srgbClr val="D9D9D9"/>
+                      </a:solidFill>
+                      <a:prstDash val="solid"/>
+                      <a:round/>
+                      <a:headEnd type="none" w="med" len="med"/>
+                      <a:tailEnd type="none" w="med" len="med"/>
+                    </a:lnT>
+                    <a:lnB w="9525" cap="flat" cmpd="sng" algn="ctr">
+                      <a:solidFill>
+                        <a:srgbClr val="D9D9D9"/>
+                      </a:solidFill>
+                      <a:prstDash val="solid"/>
+                      <a:round/>
+                      <a:headEnd type="none" w="med" len="med"/>
+                      <a:tailEnd type="none" w="med" len="med"/>
+                    </a:lnB>
+                    <a:solidFill>
+                      <a:srgbClr val="FFFFFF"/>
+                    </a:solidFill>
+                  </a:tcPr>
+                </a:tc>
+                <a:tc>
+                  <a:txBody>
+                    <a:bodyPr/>
+                    <a:lstStyle/>
+                    <a:p>
+                      <a:pPr algn="ctr" indent="0" marL="0">
+                        <a:buNone/>
+                      </a:pPr>
+                      <a:r>
+                        <a:rPr lang="en-US" sz="1200" dirty="0">
+                          <a:solidFill>
+                            <a:srgbClr val="2B2B2B"/>
+                          </a:solidFill>
+                          <a:latin typeface="Calibri" pitchFamily="34" charset="0"/>
+                          <a:ea typeface="Calibri" pitchFamily="34" charset="-122"/>
+                          <a:cs typeface="Calibri" pitchFamily="34" charset="-120"/>
+                        </a:rPr>
+                        <a:t>never (floor 75)</a:t>
+                      </a:r>
+                      <a:endParaRPr lang="en-US" sz="1200" dirty="0">
+                        <a:latin typeface="Calibri" charset="0"/>
+                        <a:ea typeface="Calibri" charset="0"/>
+                        <a:cs typeface="Calibri" charset="0"/>
+                      </a:endParaRPr>
+                    </a:p>
+                  </a:txBody>
+                  <a:tcPr marL="91440" marR="91440" marT="45720" marB="45720" anchor="ctr">
+                    <a:lnL w="9525" cap="flat" cmpd="sng" algn="ctr">
+                      <a:solidFill>
+                        <a:srgbClr val="D9D9D9"/>
+                      </a:solidFill>
+                      <a:prstDash val="solid"/>
+                      <a:round/>
+                      <a:headEnd type="none" w="med" len="med"/>
+                      <a:tailEnd type="none" w="med" len="med"/>
+                    </a:lnL>
+                    <a:lnR w="9525" cap="flat" cmpd="sng" algn="ctr">
+                      <a:solidFill>
+                        <a:srgbClr val="D9D9D9"/>
+                      </a:solidFill>
+                      <a:prstDash val="solid"/>
+                      <a:round/>
+                      <a:headEnd type="none" w="med" len="med"/>
+                      <a:tailEnd type="none" w="med" len="med"/>
+                    </a:lnR>
+                    <a:lnT w="9525" cap="flat" cmpd="sng" algn="ctr">
+                      <a:solidFill>
+                        <a:srgbClr val="D9D9D9"/>
+                      </a:solidFill>
+                      <a:prstDash val="solid"/>
+                      <a:round/>
+                      <a:headEnd type="none" w="med" len="med"/>
+                      <a:tailEnd type="none" w="med" len="med"/>
+                    </a:lnT>
+                    <a:lnB w="9525" cap="flat" cmpd="sng" algn="ctr">
+                      <a:solidFill>
+                        <a:srgbClr val="D9D9D9"/>
+                      </a:solidFill>
+                      <a:prstDash val="solid"/>
+                      <a:round/>
+                      <a:headEnd type="none" w="med" len="med"/>
+                      <a:tailEnd type="none" w="med" len="med"/>
+                    </a:lnB>
+                    <a:solidFill>
+                      <a:srgbClr val="FFFFFF"/>
+                    </a:solidFill>
+                  </a:tcPr>
+                </a:tc>
+                <a:tc>
+                  <a:txBody>
+                    <a:bodyPr/>
+                    <a:lstStyle/>
+                    <a:p>
+                      <a:pPr algn="ctr" indent="0" marL="0">
+                        <a:buNone/>
+                      </a:pPr>
+                      <a:r>
+                        <a:rPr lang="en-US" sz="1200" b="1" dirty="0">
+                          <a:solidFill>
+                            <a:srgbClr val="BE0000"/>
+                          </a:solidFill>
+                          <a:latin typeface="Calibri" pitchFamily="34" charset="0"/>
+                          <a:ea typeface="Calibri" pitchFamily="34" charset="-122"/>
+                          <a:cs typeface="Calibri" pitchFamily="34" charset="-120"/>
+                        </a:rPr>
+                        <a:t>0.5 GHz (40%)</a:t>
+                      </a:r>
+                      <a:endParaRPr lang="en-US" sz="1200" dirty="0">
+                        <a:latin typeface="Calibri" charset="0"/>
+                        <a:ea typeface="Calibri" charset="0"/>
+                        <a:cs typeface="Calibri" charset="0"/>
+                      </a:endParaRPr>
+                    </a:p>
+                  </a:txBody>
+                  <a:tcPr marL="91440" marR="91440" marT="45720" marB="45720" anchor="ctr">
+                    <a:lnL w="9525" cap="flat" cmpd="sng" algn="ctr">
+                      <a:solidFill>
+                        <a:srgbClr val="D9D9D9"/>
+                      </a:solidFill>
+                      <a:prstDash val="solid"/>
+                      <a:round/>
+                      <a:headEnd type="none" w="med" len="med"/>
+                      <a:tailEnd type="none" w="med" len="med"/>
+                    </a:lnL>
+                    <a:lnR w="9525" cap="flat" cmpd="sng" algn="ctr">
+                      <a:solidFill>
+                        <a:srgbClr val="D9D9D9"/>
+                      </a:solidFill>
+                      <a:prstDash val="solid"/>
+                      <a:round/>
+                      <a:headEnd type="none" w="med" len="med"/>
+                      <a:tailEnd type="none" w="med" len="med"/>
+                    </a:lnR>
+                    <a:lnT w="9525" cap="flat" cmpd="sng" algn="ctr">
+                      <a:solidFill>
+                        <a:srgbClr val="D9D9D9"/>
+                      </a:solidFill>
+                      <a:prstDash val="solid"/>
+                      <a:round/>
+                      <a:headEnd type="none" w="med" len="med"/>
+                      <a:tailEnd type="none" w="med" len="med"/>
+                    </a:lnT>
+                    <a:lnB w="9525" cap="flat" cmpd="sng" algn="ctr">
+                      <a:solidFill>
+                        <a:srgbClr val="D9D9D9"/>
+                      </a:solidFill>
+                      <a:prstDash val="solid"/>
+                      <a:round/>
+                      <a:headEnd type="none" w="med" len="med"/>
+                      <a:tailEnd type="none" w="med" len="med"/>
+                    </a:lnB>
+                    <a:solidFill>
+                      <a:srgbClr val="FFFFFF"/>
+                    </a:solidFill>
+                  </a:tcPr>
+                </a:tc>
+                <a:tc>
+                  <a:txBody>
+                    <a:bodyPr/>
+                    <a:lstStyle/>
+                    <a:p>
+                      <a:pPr algn="ctr" indent="0" marL="0">
+                        <a:buNone/>
+                      </a:pPr>
+                      <a:r>
+                        <a:rPr lang="en-US" sz="1200" b="1" dirty="0">
+                          <a:solidFill>
+                            <a:srgbClr val="BE0000"/>
+                          </a:solidFill>
+                          <a:latin typeface="Calibri" pitchFamily="34" charset="0"/>
+                          <a:ea typeface="Calibri" pitchFamily="34" charset="-122"/>
+                          <a:cs typeface="Calibri" pitchFamily="34" charset="-120"/>
+                        </a:rPr>
+                        <a:t>1 GHz (21%)</a:t>
+                      </a:r>
+                      <a:endParaRPr lang="en-US" sz="1200" dirty="0">
+                        <a:latin typeface="Calibri" charset="0"/>
+                        <a:ea typeface="Calibri" charset="0"/>
+                        <a:cs typeface="Calibri" charset="0"/>
+                      </a:endParaRPr>
+                    </a:p>
+                  </a:txBody>
+                  <a:tcPr marL="91440" marR="91440" marT="45720" marB="45720" anchor="ctr">
+                    <a:lnL w="9525" cap="flat" cmpd="sng" algn="ctr">
+                      <a:solidFill>
+                        <a:srgbClr val="D9D9D9"/>
+                      </a:solidFill>
+                      <a:prstDash val="solid"/>
+                      <a:round/>
+                      <a:headEnd type="none" w="med" len="med"/>
+                      <a:tailEnd type="none" w="med" len="med"/>
+                    </a:lnL>
+                    <a:lnR w="9525" cap="flat" cmpd="sng" algn="ctr">
+                      <a:solidFill>
+                        <a:srgbClr val="D9D9D9"/>
+                      </a:solidFill>
+                      <a:prstDash val="solid"/>
+                      <a:round/>
+                      <a:headEnd type="none" w="med" len="med"/>
+                      <a:tailEnd type="none" w="med" len="med"/>
+                    </a:lnR>
+                    <a:lnT w="9525" cap="flat" cmpd="sng" algn="ctr">
+                      <a:solidFill>
+                        <a:srgbClr val="D9D9D9"/>
+                      </a:solidFill>
+                      <a:prstDash val="solid"/>
+                      <a:round/>
+                      <a:headEnd type="none" w="med" len="med"/>
+                      <a:tailEnd type="none" w="med" len="med"/>
+                    </a:lnT>
+                    <a:lnB w="9525" cap="flat" cmpd="sng" algn="ctr">
+                      <a:solidFill>
+                        <a:srgbClr val="D9D9D9"/>
+                      </a:solidFill>
+                      <a:prstDash val="solid"/>
+                      <a:round/>
+                      <a:headEnd type="none" w="med" len="med"/>
+                      <a:tailEnd type="none" w="med" len="med"/>
+                    </a:lnB>
+                    <a:solidFill>
+                      <a:srgbClr val="FFFFFF"/>
+                    </a:solidFill>
+                  </a:tcPr>
+                </a:tc>
+              </a:tr>
+            </a:tbl>
+          </a:graphicData>
+        </a:graphic>
+      </p:graphicFrame>
+      <p:sp>
+        <p:nvSpPr>
+          <p:cNvPr id="5" name="Text 2"/>
+          <p:cNvSpPr/>
+          <p:nvPr/>
+        </p:nvSpPr>
+        <p:spPr>
+          <a:xfrm>
+            <a:off x="502920" y="3794760"/>
+            <a:ext cx="8138160" cy="1508760"/>
+          </a:xfrm>
+          <a:prstGeom prst="rect">
+            <a:avLst/>
+          </a:prstGeom>
+          <a:noFill/>
+          <a:ln/>
+        </p:spPr>
+        <p:txBody>
+          <a:bodyPr wrap="square" lIns="0" tIns="0" rIns="0" bIns="0" rtlCol="0" anchor="t"/>
+          <a:lstStyle/>
+          <a:p>
+            <a:pPr marL="152400" indent="-152400">
+              <a:spcAft>
+                <a:spcPts val="800"/>
+              </a:spcAft>
+              <a:buSzPct val="100000"/>
+              <a:buChar char="•"/>
+            </a:pPr>
+            <a:r>
+              <a:rPr lang="en-US" sz="1250" dirty="0">
+                <a:solidFill>
+                  <a:srgbClr val="2B2B2B"/>
+                </a:solidFill>
+                <a:latin typeface="Calibri" pitchFamily="34" charset="0"/>
+                <a:ea typeface="Calibri" pitchFamily="34" charset="-122"/>
+                <a:cs typeface="Calibri" pitchFamily="34" charset="-120"/>
+              </a:rPr>
+              <a:t>Difficulty ladder is perfectly ordered: empty never breaks (75% even on S11 + 50 MHz); F4 breaks only at the most extreme cut; F5 breaks at every reduced-hardware level.</a:t>
+            </a:r>
+            <a:endParaRPr lang="en-US" sz="1250" dirty="0"/>
+          </a:p>
+          <a:p>
+            <a:pPr marL="152400" indent="-152400">
+              <a:spcAft>
+                <a:spcPts val="800"/>
+              </a:spcAft>
+              <a:buSzPct val="100000"/>
+              <a:buChar char="•"/>
+            </a:pPr>
+            <a:r>
+              <a:rPr lang="en-US" sz="1250" dirty="0">
+                <a:solidFill>
+                  <a:srgbClr val="2B2B2B"/>
+                </a:solidFill>
+                <a:latin typeface="Calibri" pitchFamily="34" charset="0"/>
+                <a:ea typeface="Calibri" pitchFamily="34" charset="-122"/>
+                <a:cs typeface="Calibri" pitchFamily="34" charset="-120"/>
+              </a:rPr>
+              <a:t>Antennas and bandwidth trade against each other: each hardware cut moves F5's breaking point to a wider band (0.1 -&gt; 0.5 -&gt; 1 GHz).</a:t>
+            </a:r>
+            <a:endParaRPr lang="en-US" sz="1250" dirty="0"/>
+          </a:p>
+          <a:p>
+            <a:pPr marL="152400" indent="-152400">
+              <a:spcAft>
+                <a:spcPts val="800"/>
+              </a:spcAft>
+              <a:buSzPct val="100000"/>
+              <a:buChar char="•"/>
+            </a:pPr>
+            <a:r>
+              <a:rPr lang="en-US" sz="1250" dirty="0">
+                <a:solidFill>
+                  <a:srgbClr val="2B2B2B"/>
+                </a:solidFill>
+                <a:latin typeface="Calibri" pitchFamily="34" charset="0"/>
+                <a:ea typeface="Calibri" pitchFamily="34" charset="-122"/>
+                <a:cs typeface="Calibri" pitchFamily="34" charset="-120"/>
+              </a:rPr>
+              <a:t>Chip takeaway: with 2 antennas keep at least ~2 GHz of band (in the 1-4 GHz region); with the full array, bandwidth is nearly free.</a:t>
             </a:r>
             <a:endParaRPr lang="en-US" sz="1250" dirty="0"/>
           </a:p>

</xml_diff>

<commit_message>
0.1 GHz placement scan: per-phantom best slots differ; deck slide 11 + updated importance figure
Co-Authored-By: Claude Fable 5 <noreply@anthropic.com>
</commit_message>
<xml_diff>
--- a/presentation/Frequency_Reduction.pptx
+++ b/presentation/Frequency_Reduction.pptx
@@ -19,9 +19,10 @@
     <p:sldId id="267" r:id="rId13"/>
     <p:sldId id="268" r:id="rId14"/>
     <p:sldId id="269" r:id="rId15"/>
+    <p:sldId id="270" r:id="rId16"/>
   </p:sldIdLst>
   <p:notesMasterIdLst>
-    <p:notesMasterId r:id="rId16"/>
+    <p:notesMasterId r:id="rId17"/>
   </p:notesMasterIdLst>
   <p:sldSz cx="9144000" cy="5143500"/>
   <p:notesSz cx="5143500" cy="9144000"/>
@@ -979,6 +980,94 @@
             <a:fld id="{F7021451-1387-4CA6-816F-3879F97B5CBC}" type="slidenum">
               <a:rPr lang="en-US"/>
               <a:t>14</a:t>
+            </a:fld>
+            <a:endParaRPr lang="en-US"/>
+          </a:p>
+        </p:txBody>
+      </p:sp>
+    </p:spTree>
+    <p:extLst>
+      <p:ext uri="{BB962C8B-B14F-4D97-AF65-F5344CB8AC3E}">
+        <p14:creationId xmlns:p14="http://schemas.microsoft.com/office/powerpoint/2010/main" val="1024086991"/>
+      </p:ext>
+    </p:extLst>
+  </p:cSld>
+  <p:clrMapOvr>
+    <a:masterClrMapping/>
+  </p:clrMapOvr>
+</p:notes>
+</file>
+
+<file path=ppt/notesSlides/notesSlide15.xml><?xml version="1.0" encoding="utf-8"?>
+<p:notes xmlns:a="http://schemas.openxmlformats.org/drawingml/2006/main" xmlns:r="http://schemas.openxmlformats.org/officeDocument/2006/relationships" xmlns:p="http://schemas.openxmlformats.org/presentationml/2006/main">
+  <p:cSld>
+    <p:spTree>
+      <p:nvGrpSpPr>
+        <p:cNvPr id="1" name=""/>
+        <p:cNvGrpSpPr/>
+        <p:nvPr/>
+      </p:nvGrpSpPr>
+      <p:grpSpPr>
+        <a:xfrm>
+          <a:off x="0" y="0"/>
+          <a:ext cx="0" cy="0"/>
+          <a:chOff x="0" y="0"/>
+          <a:chExt cx="0" cy="0"/>
+        </a:xfrm>
+      </p:grpSpPr>
+      <p:sp>
+        <p:nvSpPr>
+          <p:cNvPr id="2" name="Slide Image Placeholder 1"/>
+          <p:cNvSpPr>
+            <a:spLocks noGrp="1" noRot="1" noChangeAspect="1"/>
+          </p:cNvSpPr>
+          <p:nvPr>
+            <p:ph type="sldImg"/>
+          </p:nvPr>
+        </p:nvSpPr>
+        <p:spPr/>
+      </p:sp>
+      <p:sp>
+        <p:nvSpPr>
+          <p:cNvPr id="3" name="Notes Placeholder 2"/>
+          <p:cNvSpPr>
+            <a:spLocks noGrp="1"/>
+          </p:cNvSpPr>
+          <p:nvPr>
+            <p:ph type="body" idx="1"/>
+          </p:nvPr>
+        </p:nvSpPr>
+        <p:spPr/>
+        <p:txBody>
+          <a:bodyPr/>
+          <a:lstStyle/>
+          <a:p>
+            <a:r>
+              <a:rPr lang="en-US" dirty="0"/>
+              <a:t/>
+            </a:r>
+            <a:endParaRPr lang="en-US" dirty="0"/>
+          </a:p>
+        </p:txBody>
+      </p:sp>
+      <p:sp>
+        <p:nvSpPr>
+          <p:cNvPr id="4" name="Slide Number Placeholder 3"/>
+          <p:cNvSpPr>
+            <a:spLocks noGrp="1"/>
+          </p:cNvSpPr>
+          <p:nvPr>
+            <p:ph type="sldNum" sz="quarter" idx="10"/>
+          </p:nvPr>
+        </p:nvSpPr>
+        <p:spPr/>
+        <p:txBody>
+          <a:bodyPr/>
+          <a:lstStyle/>
+          <a:p>
+            <a:fld id="{F7021451-1387-4CA6-816F-3879F97B5CBC}" type="slidenum">
+              <a:rPr lang="en-US"/>
+              <a:t>15</a:t>
             </a:fld>
             <a:endParaRPr lang="en-US"/>
           </a:p>
@@ -5492,6 +5581,206 @@
                 <a:ea typeface="Calibri" pitchFamily="34" charset="-122"/>
                 <a:cs typeface="Calibri" pitchFamily="34" charset="-120"/>
               </a:rPr>
+              <a:t>PART 2 · PLACEMENT, PROVEN</a:t>
+            </a:r>
+            <a:endParaRPr lang="en-US" sz="1200" dirty="0"/>
+          </a:p>
+        </p:txBody>
+      </p:sp>
+      <p:sp>
+        <p:nvSpPr>
+          <p:cNvPr id="3" name="Text 1"/>
+          <p:cNvSpPr/>
+          <p:nvPr/>
+        </p:nvSpPr>
+        <p:spPr>
+          <a:xfrm>
+            <a:off x="457200" y="512064"/>
+            <a:ext cx="8229600" cy="548640"/>
+          </a:xfrm>
+          <a:prstGeom prst="rect">
+            <a:avLst/>
+          </a:prstGeom>
+          <a:noFill/>
+          <a:ln/>
+        </p:spPr>
+        <p:txBody>
+          <a:bodyPr wrap="square" lIns="0" tIns="0" rIns="0" bIns="0" rtlCol="0" anchor="t"/>
+          <a:lstStyle/>
+          <a:p>
+            <a:pPr indent="0" marL="0">
+              <a:buNone/>
+            </a:pPr>
+            <a:r>
+              <a:rPr lang="en-US" sz="2500" b="1" dirty="0">
+                <a:solidFill>
+                  <a:srgbClr val="2A1618"/>
+                </a:solidFill>
+                <a:latin typeface="Cambria" pitchFamily="34" charset="0"/>
+                <a:ea typeface="Cambria" pitchFamily="34" charset="-122"/>
+                <a:cs typeface="Cambria" pitchFamily="34" charset="-120"/>
+              </a:rPr>
+              <a:t>Each phantom has its own best frequency</a:t>
+            </a:r>
+            <a:endParaRPr lang="en-US" sz="2500" dirty="0"/>
+          </a:p>
+        </p:txBody>
+      </p:sp>
+      <p:pic>
+        <p:nvPicPr>
+          <p:cNvPr id="4" name="Image 0" descr="assets/band_importance.png">    </p:cNvPr>
+          <p:cNvPicPr>
+            <a:picLocks noChangeAspect="1"/>
+          </p:cNvPicPr>
+          <p:nvPr/>
+        </p:nvPicPr>
+        <p:blipFill>
+          <a:blip r:embed="rId1"/>
+          <a:stretch>
+            <a:fillRect/>
+          </a:stretch>
+        </p:blipFill>
+        <p:spPr>
+          <a:xfrm>
+            <a:off x="274320" y="1371600"/>
+            <a:ext cx="8595360" cy="2633472"/>
+          </a:xfrm>
+          <a:prstGeom prst="rect">
+            <a:avLst/>
+          </a:prstGeom>
+        </p:spPr>
+      </p:pic>
+      <p:sp>
+        <p:nvSpPr>
+          <p:cNvPr id="5" name="Shape 2"/>
+          <p:cNvSpPr/>
+          <p:nvPr/>
+        </p:nvSpPr>
+        <p:spPr>
+          <a:xfrm>
+            <a:off x="457200" y="4114800"/>
+            <a:ext cx="8229600" cy="914400"/>
+          </a:xfrm>
+          <a:prstGeom prst="roundRect">
+            <a:avLst>
+              <a:gd name="adj" fmla="val 6000"/>
+            </a:avLst>
+          </a:prstGeom>
+          <a:solidFill>
+            <a:srgbClr val="FBEDED"/>
+          </a:solidFill>
+          <a:ln w="12700">
+            <a:solidFill>
+              <a:srgbClr val="E8C4C4"/>
+            </a:solidFill>
+            <a:prstDash val="solid"/>
+          </a:ln>
+        </p:spPr>
+      </p:sp>
+      <p:sp>
+        <p:nvSpPr>
+          <p:cNvPr id="6" name="Text 3"/>
+          <p:cNvSpPr/>
+          <p:nvPr/>
+        </p:nvSpPr>
+        <p:spPr>
+          <a:xfrm>
+            <a:off x="658368" y="4114800"/>
+            <a:ext cx="7863840" cy="914400"/>
+          </a:xfrm>
+          <a:prstGeom prst="rect">
+            <a:avLst/>
+          </a:prstGeom>
+          <a:noFill/>
+          <a:ln/>
+        </p:spPr>
+        <p:txBody>
+          <a:bodyPr wrap="square" lIns="0" tIns="0" rIns="0" bIns="0" rtlCol="0" anchor="ctr"/>
+          <a:lstStyle/>
+          <a:p>
+            <a:pPr indent="0" marL="0">
+              <a:buNone/>
+            </a:pPr>
+            <a:r>
+              <a:rPr lang="en-US" sz="1100" dirty="0">
+                <a:solidFill>
+                  <a:srgbClr val="2B2B2B"/>
+                </a:solidFill>
+                <a:latin typeface="Calibri" pitchFamily="34" charset="0"/>
+                <a:ea typeface="Calibri" pitchFamily="34" charset="-122"/>
+                <a:cs typeface="Calibri" pitchFamily="34" charset="-120"/>
+              </a:rPr>
+              <a:t>Sufficiency scan: train on ONLY one window and slide it across the spectrum. Best narrow slot differs by phantom: empty ~2.0 GHz (indifferent above 1.45), F4 ~3.0 (small target rewards higher frequency), F5 ~2.2-2.3 (large lossy insert forces low). The descent's 1.85-1.9 GHz slot was NOT F5's best (62.6 there vs 78.8 at 2.2-2.3), so true narrow-band floors are even higher. Pick the chip band for the worst-case target.</a:t>
+            </a:r>
+            <a:endParaRPr lang="en-US" sz="1100" dirty="0"/>
+          </a:p>
+        </p:txBody>
+      </p:sp>
+    </p:spTree>
+  </p:cSld>
+  <p:clrMapOvr>
+    <a:masterClrMapping/>
+  </p:clrMapOvr>
+</p:sld>
+</file>
+
+<file path=ppt/slides/slide12.xml><?xml version="1.0" encoding="utf-8"?>
+<p:sld xmlns:a="http://schemas.openxmlformats.org/drawingml/2006/main" xmlns:r="http://schemas.openxmlformats.org/officeDocument/2006/relationships" xmlns:p="http://schemas.openxmlformats.org/presentationml/2006/main">
+  <p:cSld name="Slide 12">
+    <p:bg>
+      <p:bgPr>
+        <a:solidFill>
+          <a:srgbClr val="FFFFFF"/>
+        </a:solidFill>
+      </p:bgPr>
+    </p:bg>
+    <p:spTree>
+      <p:nvGrpSpPr>
+        <p:cNvPr id="1" name=""/>
+        <p:cNvGrpSpPr/>
+        <p:nvPr/>
+      </p:nvGrpSpPr>
+      <p:grpSpPr>
+        <a:xfrm>
+          <a:off x="0" y="0"/>
+          <a:ext cx="0" cy="0"/>
+          <a:chOff x="0" y="0"/>
+          <a:chExt cx="0" cy="0"/>
+        </a:xfrm>
+      </p:grpSpPr>
+      <p:sp>
+        <p:nvSpPr>
+          <p:cNvPr id="2" name="Text 0"/>
+          <p:cNvSpPr/>
+          <p:nvPr/>
+        </p:nvSpPr>
+        <p:spPr>
+          <a:xfrm>
+            <a:off x="457200" y="237744"/>
+            <a:ext cx="8229600" cy="256032"/>
+          </a:xfrm>
+          <a:prstGeom prst="rect">
+            <a:avLst/>
+          </a:prstGeom>
+          <a:noFill/>
+          <a:ln/>
+        </p:spPr>
+        <p:txBody>
+          <a:bodyPr wrap="square" lIns="0" tIns="0" rIns="0" bIns="0" rtlCol="0" anchor="t"/>
+          <a:lstStyle/>
+          <a:p>
+            <a:pPr indent="0" marL="0">
+              <a:buNone/>
+            </a:pPr>
+            <a:r>
+              <a:rPr lang="en-US" sz="1200" b="1" spc="200" kern="0" dirty="0">
+                <a:solidFill>
+                  <a:srgbClr val="BE0000"/>
+                </a:solidFill>
+                <a:latin typeface="Calibri" pitchFamily="34" charset="0"/>
+                <a:ea typeface="Calibri" pitchFamily="34" charset="-122"/>
+                <a:cs typeface="Calibri" pitchFamily="34" charset="-120"/>
+              </a:rPr>
               <a:t>PART 2 · THE DESCENT</a:t>
             </a:r>
             <a:endParaRPr lang="en-US" sz="1200" dirty="0"/>
@@ -5569,9 +5858,9 @@
 </p:sld>
 </file>
 
-<file path=ppt/slides/slide12.xml><?xml version="1.0" encoding="utf-8"?>
+<file path=ppt/slides/slide13.xml><?xml version="1.0" encoding="utf-8"?>
 <p:sld xmlns:a="http://schemas.openxmlformats.org/drawingml/2006/main" xmlns:r="http://schemas.openxmlformats.org/officeDocument/2006/relationships" xmlns:p="http://schemas.openxmlformats.org/presentationml/2006/main">
-  <p:cSld name="Slide 12">
+  <p:cSld name="Slide 13">
     <p:bg>
       <p:bgPr>
         <a:solidFill>
@@ -5673,7 +5962,7 @@
       </p:sp>
       <p:graphicFrame>
         <p:nvGraphicFramePr>
-          <p:cNvPr id="13" name="Table 0"/>
+          <p:cNvPr id="14" name="Table 0"/>
           <p:cNvGraphicFramePr>
             <a:graphicFrameLocks noGrp="1"/>
           </p:cNvGraphicFramePr>
@@ -7147,9 +7436,9 @@
 </p:sld>
 </file>
 
-<file path=ppt/slides/slide13.xml><?xml version="1.0" encoding="utf-8"?>
+<file path=ppt/slides/slide14.xml><?xml version="1.0" encoding="utf-8"?>
 <p:sld xmlns:a="http://schemas.openxmlformats.org/drawingml/2006/main" xmlns:r="http://schemas.openxmlformats.org/officeDocument/2006/relationships" xmlns:p="http://schemas.openxmlformats.org/presentationml/2006/main">
-  <p:cSld name="Slide 13">
+  <p:cSld name="Slide 14">
     <p:bg>
       <p:bgPr>
         <a:solidFill>
@@ -7347,9 +7636,9 @@
 </p:sld>
 </file>
 
-<file path=ppt/slides/slide14.xml><?xml version="1.0" encoding="utf-8"?>
+<file path=ppt/slides/slide15.xml><?xml version="1.0" encoding="utf-8"?>
 <p:sld xmlns:a="http://schemas.openxmlformats.org/drawingml/2006/main" xmlns:r="http://schemas.openxmlformats.org/officeDocument/2006/relationships" xmlns:p="http://schemas.openxmlformats.org/presentationml/2006/main">
-  <p:cSld name="Slide 14">
+  <p:cSld name="Slide 15">
     <p:bg>
       <p:bgPr>
         <a:solidFill>
@@ -7451,7 +7740,7 @@
       </p:sp>
       <p:graphicFrame>
         <p:nvGraphicFramePr>
-          <p:cNvPr id="15" name="Table 0"/>
+          <p:cNvPr id="16" name="Table 0"/>
           <p:cNvGraphicFramePr>
             <a:graphicFrameLocks noGrp="1"/>
           </p:cNvGraphicFramePr>

</xml_diff>

<commit_message>
Break descent v2: per-phantom best-center ladders; F4's break was placement, F5's is physics
Co-Authored-By: Claude Fable 5 <noreply@anthropic.com>
</commit_message>
<xml_diff>
--- a/presentation/Frequency_Reduction.pptx
+++ b/presentation/Frequency_Reduction.pptx
@@ -20,9 +20,10 @@
     <p:sldId id="268" r:id="rId14"/>
     <p:sldId id="269" r:id="rId15"/>
     <p:sldId id="270" r:id="rId16"/>
+    <p:sldId id="271" r:id="rId17"/>
   </p:sldIdLst>
   <p:notesMasterIdLst>
-    <p:notesMasterId r:id="rId17"/>
+    <p:notesMasterId r:id="rId18"/>
   </p:notesMasterIdLst>
   <p:sldSz cx="9144000" cy="5143500"/>
   <p:notesSz cx="5143500" cy="9144000"/>
@@ -1068,6 +1069,94 @@
             <a:fld id="{F7021451-1387-4CA6-816F-3879F97B5CBC}" type="slidenum">
               <a:rPr lang="en-US"/>
               <a:t>15</a:t>
+            </a:fld>
+            <a:endParaRPr lang="en-US"/>
+          </a:p>
+        </p:txBody>
+      </p:sp>
+    </p:spTree>
+    <p:extLst>
+      <p:ext uri="{BB962C8B-B14F-4D97-AF65-F5344CB8AC3E}">
+        <p14:creationId xmlns:p14="http://schemas.microsoft.com/office/powerpoint/2010/main" val="1024086991"/>
+      </p:ext>
+    </p:extLst>
+  </p:cSld>
+  <p:clrMapOvr>
+    <a:masterClrMapping/>
+  </p:clrMapOvr>
+</p:notes>
+</file>
+
+<file path=ppt/notesSlides/notesSlide16.xml><?xml version="1.0" encoding="utf-8"?>
+<p:notes xmlns:a="http://schemas.openxmlformats.org/drawingml/2006/main" xmlns:r="http://schemas.openxmlformats.org/officeDocument/2006/relationships" xmlns:p="http://schemas.openxmlformats.org/presentationml/2006/main">
+  <p:cSld>
+    <p:spTree>
+      <p:nvGrpSpPr>
+        <p:cNvPr id="1" name=""/>
+        <p:cNvGrpSpPr/>
+        <p:nvPr/>
+      </p:nvGrpSpPr>
+      <p:grpSpPr>
+        <a:xfrm>
+          <a:off x="0" y="0"/>
+          <a:ext cx="0" cy="0"/>
+          <a:chOff x="0" y="0"/>
+          <a:chExt cx="0" cy="0"/>
+        </a:xfrm>
+      </p:grpSpPr>
+      <p:sp>
+        <p:nvSpPr>
+          <p:cNvPr id="2" name="Slide Image Placeholder 1"/>
+          <p:cNvSpPr>
+            <a:spLocks noGrp="1" noRot="1" noChangeAspect="1"/>
+          </p:cNvSpPr>
+          <p:nvPr>
+            <p:ph type="sldImg"/>
+          </p:nvPr>
+        </p:nvSpPr>
+        <p:spPr/>
+      </p:sp>
+      <p:sp>
+        <p:nvSpPr>
+          <p:cNvPr id="3" name="Notes Placeholder 2"/>
+          <p:cNvSpPr>
+            <a:spLocks noGrp="1"/>
+          </p:cNvSpPr>
+          <p:nvPr>
+            <p:ph type="body" idx="1"/>
+          </p:nvPr>
+        </p:nvSpPr>
+        <p:spPr/>
+        <p:txBody>
+          <a:bodyPr/>
+          <a:lstStyle/>
+          <a:p>
+            <a:r>
+              <a:rPr lang="en-US" dirty="0"/>
+              <a:t/>
+            </a:r>
+            <a:endParaRPr lang="en-US" dirty="0"/>
+          </a:p>
+        </p:txBody>
+      </p:sp>
+      <p:sp>
+        <p:nvSpPr>
+          <p:cNvPr id="4" name="Slide Number Placeholder 3"/>
+          <p:cNvSpPr>
+            <a:spLocks noGrp="1"/>
+          </p:cNvSpPr>
+          <p:nvPr>
+            <p:ph type="sldNum" sz="quarter" idx="10"/>
+          </p:nvPr>
+        </p:nvSpPr>
+        <p:spPr/>
+        <p:txBody>
+          <a:bodyPr/>
+          <a:lstStyle/>
+          <a:p>
+            <a:fld id="{F7021451-1387-4CA6-816F-3879F97B5CBC}" type="slidenum">
+              <a:rPr lang="en-US"/>
+              <a:t>16</a:t>
             </a:fld>
             <a:endParaRPr lang="en-US"/>
           </a:p>
@@ -7693,6 +7782,206 @@
                 <a:ea typeface="Calibri" pitchFamily="34" charset="-122"/>
                 <a:cs typeface="Calibri" pitchFamily="34" charset="-120"/>
               </a:rPr>
+              <a:t>PART 3 · BREAK MAP V2</a:t>
+            </a:r>
+            <a:endParaRPr lang="en-US" sz="1200" dirty="0"/>
+          </a:p>
+        </p:txBody>
+      </p:sp>
+      <p:sp>
+        <p:nvSpPr>
+          <p:cNvPr id="3" name="Text 1"/>
+          <p:cNvSpPr/>
+          <p:nvPr/>
+        </p:nvSpPr>
+        <p:spPr>
+          <a:xfrm>
+            <a:off x="457200" y="512064"/>
+            <a:ext cx="8229600" cy="548640"/>
+          </a:xfrm>
+          <a:prstGeom prst="rect">
+            <a:avLst/>
+          </a:prstGeom>
+          <a:noFill/>
+          <a:ln/>
+        </p:spPr>
+        <p:txBody>
+          <a:bodyPr wrap="square" lIns="0" tIns="0" rIns="0" bIns="0" rtlCol="0" anchor="t"/>
+          <a:lstStyle/>
+          <a:p>
+            <a:pPr indent="0" marL="0">
+              <a:buNone/>
+            </a:pPr>
+            <a:r>
+              <a:rPr lang="en-US" sz="2500" b="1" dirty="0">
+                <a:solidFill>
+                  <a:srgbClr val="2A1618"/>
+                </a:solidFill>
+                <a:latin typeface="Cambria" pitchFamily="34" charset="0"/>
+                <a:ea typeface="Cambria" pitchFamily="34" charset="-122"/>
+                <a:cs typeface="Cambria" pitchFamily="34" charset="-120"/>
+              </a:rPr>
+              <a:t>Same descent, but each phantom aims at its own best frequency</a:t>
+            </a:r>
+            <a:endParaRPr lang="en-US" sz="2500" dirty="0"/>
+          </a:p>
+        </p:txBody>
+      </p:sp>
+      <p:pic>
+        <p:nvPicPr>
+          <p:cNvPr id="4" name="Image 0" descr="assets/break_descent_map_best.png">    </p:cNvPr>
+          <p:cNvPicPr>
+            <a:picLocks noChangeAspect="1"/>
+          </p:cNvPicPr>
+          <p:nvPr/>
+        </p:nvPicPr>
+        <p:blipFill>
+          <a:blip r:embed="rId1"/>
+          <a:stretch>
+            <a:fillRect/>
+          </a:stretch>
+        </p:blipFill>
+        <p:spPr>
+          <a:xfrm>
+            <a:off x="228600" y="1417320"/>
+            <a:ext cx="8686800" cy="2578608"/>
+          </a:xfrm>
+          <a:prstGeom prst="rect">
+            <a:avLst/>
+          </a:prstGeom>
+        </p:spPr>
+      </p:pic>
+      <p:sp>
+        <p:nvSpPr>
+          <p:cNvPr id="5" name="Shape 2"/>
+          <p:cNvSpPr/>
+          <p:nvPr/>
+        </p:nvSpPr>
+        <p:spPr>
+          <a:xfrm>
+            <a:off x="457200" y="4160520"/>
+            <a:ext cx="8229600" cy="960120"/>
+          </a:xfrm>
+          <a:prstGeom prst="roundRect">
+            <a:avLst>
+              <a:gd name="adj" fmla="val 5714"/>
+            </a:avLst>
+          </a:prstGeom>
+          <a:solidFill>
+            <a:srgbClr val="FBEDED"/>
+          </a:solidFill>
+          <a:ln w="12700">
+            <a:solidFill>
+              <a:srgbClr val="E8C4C4"/>
+            </a:solidFill>
+            <a:prstDash val="solid"/>
+          </a:ln>
+        </p:spPr>
+      </p:sp>
+      <p:sp>
+        <p:nvSpPr>
+          <p:cNvPr id="6" name="Text 3"/>
+          <p:cNvSpPr/>
+          <p:nvPr/>
+        </p:nvSpPr>
+        <p:spPr>
+          <a:xfrm>
+            <a:off x="658368" y="4160520"/>
+            <a:ext cx="7863840" cy="960120"/>
+          </a:xfrm>
+          <a:prstGeom prst="rect">
+            <a:avLst/>
+          </a:prstGeom>
+          <a:noFill/>
+          <a:ln/>
+        </p:spPr>
+        <p:txBody>
+          <a:bodyPr wrap="square" lIns="0" tIns="0" rIns="0" bIns="0" rtlCol="0" anchor="ctr"/>
+          <a:lstStyle/>
+          <a:p>
+            <a:pPr indent="0" marL="0">
+              <a:buNone/>
+            </a:pPr>
+            <a:r>
+              <a:rPr lang="en-US" sz="1100" dirty="0">
+                <a:solidFill>
+                  <a:srgbClr val="2B2B2B"/>
+                </a:solidFill>
+                <a:latin typeface="Calibri" pitchFamily="34" charset="0"/>
+                <a:ea typeface="Calibri" pitchFamily="34" charset="-122"/>
+                <a:cs typeface="Calibri" pitchFamily="34" charset="-120"/>
+              </a:rPr>
+              <a:t>Re-centered ladders (empty -&gt; 2.0 GHz, F4 -&gt; 3.0, F5 -&gt; 2.25). F4's single-antenna break vanishes entirely (70% at 50 MHz vs broken at 0.5 GHz before): its 'break' was bad placement, not missing information. F5's floors rise ~10-15 points and it survives one step further, but its reduced-hardware breaks remain - those are physics. Caveat: best centers came from full-array scans and shift slightly at reduced hardware (empty on S11 alone did better at the old 1.85-1.9 slot).</a:t>
+            </a:r>
+            <a:endParaRPr lang="en-US" sz="1100" dirty="0"/>
+          </a:p>
+        </p:txBody>
+      </p:sp>
+    </p:spTree>
+  </p:cSld>
+  <p:clrMapOvr>
+    <a:masterClrMapping/>
+  </p:clrMapOvr>
+</p:sld>
+</file>
+
+<file path=ppt/slides/slide16.xml><?xml version="1.0" encoding="utf-8"?>
+<p:sld xmlns:a="http://schemas.openxmlformats.org/drawingml/2006/main" xmlns:r="http://schemas.openxmlformats.org/officeDocument/2006/relationships" xmlns:p="http://schemas.openxmlformats.org/presentationml/2006/main">
+  <p:cSld name="Slide 16">
+    <p:bg>
+      <p:bgPr>
+        <a:solidFill>
+          <a:srgbClr val="FFFFFF"/>
+        </a:solidFill>
+      </p:bgPr>
+    </p:bg>
+    <p:spTree>
+      <p:nvGrpSpPr>
+        <p:cNvPr id="1" name=""/>
+        <p:cNvGrpSpPr/>
+        <p:nvPr/>
+      </p:nvGrpSpPr>
+      <p:grpSpPr>
+        <a:xfrm>
+          <a:off x="0" y="0"/>
+          <a:ext cx="0" cy="0"/>
+          <a:chOff x="0" y="0"/>
+          <a:chExt cx="0" cy="0"/>
+        </a:xfrm>
+      </p:grpSpPr>
+      <p:sp>
+        <p:nvSpPr>
+          <p:cNvPr id="2" name="Text 0"/>
+          <p:cNvSpPr/>
+          <p:nvPr/>
+        </p:nvSpPr>
+        <p:spPr>
+          <a:xfrm>
+            <a:off x="457200" y="237744"/>
+            <a:ext cx="8229600" cy="256032"/>
+          </a:xfrm>
+          <a:prstGeom prst="rect">
+            <a:avLst/>
+          </a:prstGeom>
+          <a:noFill/>
+          <a:ln/>
+        </p:spPr>
+        <p:txBody>
+          <a:bodyPr wrap="square" lIns="0" tIns="0" rIns="0" bIns="0" rtlCol="0" anchor="t"/>
+          <a:lstStyle/>
+          <a:p>
+            <a:pPr indent="0" marL="0">
+              <a:buNone/>
+            </a:pPr>
+            <a:r>
+              <a:rPr lang="en-US" sz="1200" b="1" spc="200" kern="0" dirty="0">
+                <a:solidFill>
+                  <a:srgbClr val="BE0000"/>
+                </a:solidFill>
+                <a:latin typeface="Calibri" pitchFamily="34" charset="0"/>
+                <a:ea typeface="Calibri" pitchFamily="34" charset="-122"/>
+                <a:cs typeface="Calibri" pitchFamily="34" charset="-120"/>
+              </a:rPr>
               <a:t>PART 3 · VERDICT</a:t>
             </a:r>
             <a:endParaRPr lang="en-US" sz="1200" dirty="0"/>
@@ -7740,7 +8029,7 @@
       </p:sp>
       <p:graphicFrame>
         <p:nvGraphicFramePr>
-          <p:cNvPr id="16" name="Table 0"/>
+          <p:cNvPr id="17" name="Table 0"/>
           <p:cNvGraphicFramePr>
             <a:graphicFrameLocks noGrp="1"/>
           </p:cNvGraphicFramePr>

</xml_diff>

<commit_message>
Rebuild band deck: v2 map slide with empty on original 1.875 GHz bands
Co-Authored-By: Claude Fable 5 <noreply@anthropic.com>
</commit_message>
<xml_diff>
--- a/presentation/Frequency_Reduction.pptx
+++ b/presentation/Frequency_Reduction.pptx
@@ -7903,7 +7903,7 @@
               <a:buNone/>
             </a:pPr>
             <a:r>
-              <a:rPr lang="en-US" sz="1100" dirty="0">
+              <a:rPr lang="en-US" sz="1050" dirty="0">
                 <a:solidFill>
                   <a:srgbClr val="2B2B2B"/>
                 </a:solidFill>
@@ -7911,9 +7911,9 @@
                 <a:ea typeface="Calibri" pitchFamily="34" charset="-122"/>
                 <a:cs typeface="Calibri" pitchFamily="34" charset="-120"/>
               </a:rPr>
-              <a:t>Re-centered ladders (empty -&gt; 2.0 GHz, F4 -&gt; 3.0, F5 -&gt; 2.25). F4's single-antenna break vanishes entirely (70% at 50 MHz vs broken at 0.5 GHz before): its 'break' was bad placement, not missing information. F5's floors rise ~10-15 points and it survives one step further, but its reduced-hardware breaks remain - those are physics. Caveat: best centers came from full-array scans and shift slightly at reduced hardware (empty on S11 alone did better at the old 1.85-1.9 slot).</a:t>
+              <a:t>Re-centered ladders (F4 -&gt; 3.0 GHz, F5 -&gt; 2.25). F4's single-antenna break vanishes entirely (70% at 50 MHz vs broken at 0.5 GHz before): its 'break' was bad placement, not missing information. F5's floors rise ~10-15 points and it survives one step further, but its reduced-hardware breaks remain - those are physics. Empty keeps its ORIGINAL ~1.875 GHz bands: its full-array placement scan was saturated (99-100 everywhere), so the 'optimized' 2.0 pick was noise and measurably worse at single antenna (71/59 vs 76/75) - optimize placement at the hardware you deploy.</a:t>
             </a:r>
-            <a:endParaRPr lang="en-US" sz="1100" dirty="0"/>
+            <a:endParaRPr lang="en-US" sz="1050" dirty="0"/>
           </a:p>
         </p:txBody>
       </p:sp>

</xml_diff>

<commit_message>
Deck: rewrite noteboxes/bullets to objective data descriptions
Co-Authored-By: Claude Fable 5 <noreply@anthropic.com>
</commit_message>
<xml_diff>
--- a/presentation/Frequency_Reduction.pptx
+++ b/presentation/Frequency_Reduction.pptx
@@ -2456,7 +2456,7 @@
                 <a:ea typeface="Calibri" pitchFamily="34" charset="-122"/>
                 <a:cs typeface="Calibri" pitchFamily="34" charset="-120"/>
               </a:rPr>
-              <a:t>recommended band</a:t>
+              <a:t>matches full-band accuracy</a:t>
             </a:r>
             <a:endParaRPr lang="en-US" sz="1150" dirty="0"/>
           </a:p>
@@ -2761,7 +2761,7 @@
                 <a:ea typeface="Cambria" pitchFamily="34" charset="-122"/>
                 <a:cs typeface="Cambria" pitchFamily="34" charset="-120"/>
               </a:rPr>
-              <a:t>A 0.25 GHz window: placement is everything</a:t>
+              <a:t>Nine 0.25 GHz windows across the span</a:t>
             </a:r>
             <a:endParaRPr lang="en-US" sz="2500" dirty="0"/>
           </a:p>
@@ -5599,7 +5599,7 @@
                 <a:ea typeface="Calibri" pitchFamily="34" charset="-122"/>
                 <a:cs typeface="Calibri" pitchFamily="34" charset="-120"/>
               </a:rPr>
-              <a:t>Best slot: 2-2.25 GHz (highlighted; also far more stable than 1.75-2). Red rows: below ~1.25 GHz even the EMPTY phantom breaks the 50% line. Bandwidth is survivable; bad placement is not.</a:t>
+              <a:t>Highest window: 2-2.25 GHz (highlighted), with lower fold sigma than 1.75-2. In the red rows (below ~1.25 GHz) empty and F4 score below 50%.</a:t>
             </a:r>
             <a:endParaRPr lang="en-US" sz="1200" dirty="0"/>
           </a:p>
@@ -5670,7 +5670,7 @@
                 <a:ea typeface="Calibri" pitchFamily="34" charset="-122"/>
                 <a:cs typeface="Calibri" pitchFamily="34" charset="-120"/>
               </a:rPr>
-              <a:t>PART 2 · PLACEMENT, PROVEN</a:t>
+              <a:t>PART 2 · PLACEMENT SCAN</a:t>
             </a:r>
             <a:endParaRPr lang="en-US" sz="1200" dirty="0"/>
           </a:p>
@@ -5709,7 +5709,7 @@
                 <a:ea typeface="Cambria" pitchFamily="34" charset="-122"/>
                 <a:cs typeface="Cambria" pitchFamily="34" charset="-120"/>
               </a:rPr>
-              <a:t>Each phantom has its own best frequency</a:t>
+              <a:t>Each phantom has a different best frequency</a:t>
             </a:r>
             <a:endParaRPr lang="en-US" sz="2500" dirty="0"/>
           </a:p>
@@ -5799,7 +5799,7 @@
                 <a:ea typeface="Calibri" pitchFamily="34" charset="-122"/>
                 <a:cs typeface="Calibri" pitchFamily="34" charset="-120"/>
               </a:rPr>
-              <a:t>Sufficiency scan: train on ONLY one window and slide it across the spectrum. Best narrow slot differs by phantom: empty ~2.0 GHz (indifferent above 1.45), F4 ~3.0 (small target rewards higher frequency), F5 ~2.2-2.3 (large lossy insert forces low). The descent's 1.85-1.9 GHz slot was NOT F5's best (62.6 there vs 78.8 at 2.2-2.3), so true narrow-band floors are even higher. Pick the chip band for the worst-case target.</a:t>
+              <a:t>The model is trained on only one window at a time, slid across the spectrum. Best narrow slot per phantom: empty ~2.0 GHz (99+ everywhere above 1.45), F4 ~3.0 GHz, F5 ~2.2-2.3 GHz. At 100 MHz width F5 scores 78.8 at 2.2-2.3 vs 62.6 at 1.825-1.925, the slot used in the Part 2 descent.</a:t>
             </a:r>
             <a:endParaRPr lang="en-US" sz="1100" dirty="0"/>
           </a:p>
@@ -7511,7 +7511,7 @@
                 <a:ea typeface="Calibri" pitchFamily="34" charset="-122"/>
                 <a:cs typeface="Calibri" pitchFamily="34" charset="-120"/>
               </a:rPr>
-              <a:t>With all 16 S-parameters and a well-placed window, bandwidth alone cannot push any phantom below 50%: even a 50 MHz sliver holds 99 / 90 / 60. F5 fails softly (degraded, then session-unstable below 1 GHz). Breaking for real requires combining the band cut with hardware reduction; that adaptive descent is Part 3.</a:t>
+              <a:t>With all 16 S-parameters, no phantom scores below 50% at any width: at 50 MHz the floors are 99.3 / 90.4 / 59.6. F5 crosses the degraded tier at 0.5 GHz and the unstable tier at 1 GHz. Part 3 repeats the descent with reduced hardware.</a:t>
             </a:r>
             <a:endParaRPr lang="en-US" sz="1250" dirty="0"/>
           </a:p>
@@ -7711,7 +7711,7 @@
                 <a:ea typeface="Calibri" pitchFamily="34" charset="-122"/>
                 <a:cs typeface="Calibri" pitchFamily="34" charset="-120"/>
               </a:rPr>
-              <a:t>Adaptive descent: bands narrow left to right at the best placement per width; once a phantom scores below 50% (black box) it stops descending at that hardware level. Blank cells were skipped after the break. Empty stays green everywhere.</a:t>
+              <a:t>Bands narrow left to right at the best placement per width; once a phantom scores below 50% (black box) it stops descending at that hardware level. Blank cells were skipped after the break. Empty does not cross 50% in any cell.</a:t>
             </a:r>
             <a:endParaRPr lang="en-US" sz="1200" dirty="0"/>
           </a:p>
@@ -7821,7 +7821,7 @@
                 <a:ea typeface="Cambria" pitchFamily="34" charset="-122"/>
                 <a:cs typeface="Cambria" pitchFamily="34" charset="-120"/>
               </a:rPr>
-              <a:t>Same descent, but each phantom aims at its own best frequency</a:t>
+              <a:t>Same descent with per-phantom band centers</a:t>
             </a:r>
             <a:endParaRPr lang="en-US" sz="2500" dirty="0"/>
           </a:p>
@@ -7911,7 +7911,7 @@
                 <a:ea typeface="Calibri" pitchFamily="34" charset="-122"/>
                 <a:cs typeface="Calibri" pitchFamily="34" charset="-120"/>
               </a:rPr>
-              <a:t>Re-centered ladders (F4 -&gt; 3.0 GHz, F5 -&gt; 2.25). F4's single-antenna break vanishes entirely (70% at 50 MHz vs broken at 0.5 GHz before): its 'break' was bad placement, not missing information. F5's floors rise ~10-15 points and it survives one step further, but its reduced-hardware breaks remain - those are physics. Empty keeps its ORIGINAL ~1.875 GHz bands: its full-array placement scan was saturated (99-100 everywhere), so the 'optimized' 2.0 pick was noise and measurably worse at single antenna (71/59 vs 76/75) - optimize placement at the hardware you deploy.</a:t>
+              <a:t>Bands re-centered per phantom: F4 -&gt; 3.0 GHz, F5 -&gt; 2.25 GHz. Empty keeps its original ~1.875 GHz bands: its full-array scan scored 99-100 in every window, and at single antenna the original slot scored higher (76/75 vs 71/59 at 0.1/0.05 GHz). With re-centered bands, F4's single-antenna row no longer crosses 50% (70.5 at 50 MHz vs 39.7 at 0.5 GHz before) and F5's sub-50% cells shift one column narrower.</a:t>
             </a:r>
             <a:endParaRPr lang="en-US" sz="1050" dirty="0"/>
           </a:p>
@@ -7982,7 +7982,7 @@
                 <a:ea typeface="Calibri" pitchFamily="34" charset="-122"/>
                 <a:cs typeface="Calibri" pitchFamily="34" charset="-120"/>
               </a:rPr>
-              <a:t>PART 3 · VERDICT</a:t>
+              <a:t>PART 3 · SUMMARY</a:t>
             </a:r>
             <a:endParaRPr lang="en-US" sz="1200" dirty="0"/>
           </a:p>
@@ -8021,7 +8021,7 @@
                 <a:ea typeface="Cambria" pitchFamily="34" charset="-122"/>
                 <a:cs typeface="Cambria" pitchFamily="34" charset="-120"/>
               </a:rPr>
-              <a:t>Where each phantom finally breaks (&lt;50%)</a:t>
+              <a:t>First band below 50%, original descent</a:t>
             </a:r>
             <a:endParaRPr lang="en-US" sz="2500" dirty="0"/>
           </a:p>
@@ -9740,7 +9740,7 @@
                 <a:ea typeface="Calibri" pitchFamily="34" charset="-122"/>
                 <a:cs typeface="Calibri" pitchFamily="34" charset="-120"/>
               </a:rPr>
-              <a:t>Difficulty ladder is perfectly ordered: empty never breaks (75% even on S11 + 50 MHz); F4 breaks only at the most extreme cut; F5 breaks at every reduced-hardware level.</a:t>
+              <a:t>Empty never scores below 50% in any cell. F4 crosses 50% only at 1 antenna + 0.5 GHz (and not at all with re-centered bands). F5 crosses 50% at every reduced-hardware level.</a:t>
             </a:r>
             <a:endParaRPr lang="en-US" sz="1250" dirty="0"/>
           </a:p>
@@ -9761,28 +9761,7 @@
                 <a:ea typeface="Calibri" pitchFamily="34" charset="-122"/>
                 <a:cs typeface="Calibri" pitchFamily="34" charset="-120"/>
               </a:rPr>
-              <a:t>Antennas and bandwidth trade against each other: each hardware cut moves F5's breaking point to a wider band (0.1 -&gt; 0.5 -&gt; 1 GHz).</a:t>
-            </a:r>
-            <a:endParaRPr lang="en-US" sz="1250" dirty="0"/>
-          </a:p>
-          <a:p>
-            <a:pPr marL="152400" indent="-152400">
-              <a:spcAft>
-                <a:spcPts val="800"/>
-              </a:spcAft>
-              <a:buSzPct val="100000"/>
-              <a:buChar char="•"/>
-            </a:pPr>
-            <a:r>
-              <a:rPr lang="en-US" sz="1250" dirty="0">
-                <a:solidFill>
-                  <a:srgbClr val="2B2B2B"/>
-                </a:solidFill>
-                <a:latin typeface="Calibri" pitchFamily="34" charset="0"/>
-                <a:ea typeface="Calibri" pitchFamily="34" charset="-122"/>
-                <a:cs typeface="Calibri" pitchFamily="34" charset="-120"/>
-              </a:rPr>
-              <a:t>Chip takeaway: with 2 antennas keep at least ~2 GHz of band (in the 1-4 GHz region); with the full array, bandwidth is nearly free.</a:t>
+              <a:t>F5's first sub-50% band widens as hardware is reduced: 0.1 GHz (4 ant refl) -&gt; 0.5 GHz (2 ant) -&gt; 1 GHz (2 ant refl, 1 ant).</a:t>
             </a:r>
             <a:endParaRPr lang="en-US" sz="1250" dirty="0"/>
           </a:p>
@@ -10628,7 +10607,7 @@
                 <a:ea typeface="Cambria" pitchFamily="34" charset="-122"/>
                 <a:cs typeface="Cambria" pitchFamily="34" charset="-120"/>
               </a:rPr>
-              <a:t>A 2 GHz window: the low-mid band wins</a:t>
+              <a:t>A 2 GHz window slid across the sweep</a:t>
             </a:r>
             <a:endParaRPr lang="en-US" sz="2500" dirty="0"/>
           </a:p>
@@ -12818,7 +12797,7 @@
                 <a:ea typeface="Calibri" pitchFamily="34" charset="-122"/>
                 <a:cs typeface="Calibri" pitchFamily="34" charset="-120"/>
               </a:rPr>
-              <a:t>The 2-4 GHz window wins. Above 4 GHz, F5 collapses to ~70%: the large lossy glandular insert attenuates high-frequency energy before it reaches interior positions. The empty phantom is band-agnostic.</a:t>
+              <a:t>2-4 GHz is the highest-scoring 2 GHz window. Above 4 GHz, F5 drops to ~70%. The empty phantom scores 99.4 in every window.</a:t>
             </a:r>
             <a:endParaRPr lang="en-US" sz="1300" dirty="0"/>
           </a:p>
@@ -12928,7 +12907,7 @@
                 <a:ea typeface="Cambria" pitchFamily="34" charset="-122"/>
                 <a:cs typeface="Cambria" pitchFamily="34" charset="-120"/>
               </a:rPr>
-              <a:t>Expanding around 2-4 GHz: the knee is at 4 GHz</a:t>
+              <a:t>Expanding the window around 2-4 GHz</a:t>
             </a:r>
             <a:endParaRPr lang="en-US" sz="2500" dirty="0"/>
           </a:p>
@@ -15118,7 +15097,7 @@
                 <a:ea typeface="Calibri" pitchFamily="34" charset="-122"/>
                 <a:cs typeface="Calibri" pitchFamily="34" charset="-120"/>
               </a:rPr>
-              <a:t>1-5 GHz (4 GHz bandwidth, 3 GHz centre) recovers full-band accuracy on every phantom, including 100% on F5. Going wider adds nothing; going narrower costs F5 3-7 points. Half the bandwidth, zero accuracy cost.</a:t>
+              <a:t>1-5 GHz (4 GHz bandwidth, 3 GHz centre) matches full-band accuracy on all three phantoms, including 100% on F5. 0.5-5.5 GHz scores the same; 1.5-4.5 and 2-4 GHz score 3-7 points lower on F5.</a:t>
             </a:r>
             <a:endParaRPr lang="en-US" sz="1300" dirty="0"/>
           </a:p>
@@ -17210,7 +17189,7 @@
                 <a:ea typeface="Calibri" pitchFamily="34" charset="-122"/>
                 <a:cs typeface="Calibri" pitchFamily="34" charset="-120"/>
               </a:rPr>
-              <a:t>The reductions compound on F5: a band cut that is free with the full array costs 3-6 points once antennas or transmission paths are also removed. Best reduced operating point: 4 antennas, reflection-only, 1-5 GHz = 95% on the hardest phantom.</a:t>
+              <a:t>With the full array, restricting to 1-5 GHz left accuracy unchanged; with reduced antennas the same restriction scores 3-6 points lower on F5 than full band. 4 antennas reflection-only at 1-5 GHz: 94.9 on F5.</a:t>
             </a:r>
             <a:endParaRPr lang="en-US" sz="1300" dirty="0"/>
           </a:p>
@@ -17320,7 +17299,7 @@
                 <a:ea typeface="Cambria" pitchFamily="34" charset="-122"/>
                 <a:cs typeface="Cambria" pitchFamily="34" charset="-120"/>
               </a:rPr>
-              <a:t>The same sweep with one antenna confirms the band</a:t>
+              <a:t>The same window sweep with one antenna</a:t>
             </a:r>
             <a:endParaRPr lang="en-US" sz="2500" dirty="0"/>
           </a:p>
@@ -19852,7 +19831,7 @@
                 <a:ea typeface="Calibri" pitchFamily="34" charset="-122"/>
                 <a:cs typeface="Calibri" pitchFamily="34" charset="-120"/>
               </a:rPr>
-              <a:t>2-4 GHz wins again, so the band choice is robust; but with one antenna there is no knee - accuracy climbs to ~5 GHz. Antennas and bandwidth are partially interchangeable information budgets.</a:t>
+              <a:t>With one antenna, 2-4 GHz is again the highest 2 GHz window. F5 accuracy rises with width through ~5 GHz (62.6 at 2 GHz -&gt; 74.8 at 5 GHz). The 0.1-2 GHz window scores 25.3 on F5 with one antenna vs 90.9 with the full array.</a:t>
             </a:r>
             <a:endParaRPr lang="en-US" sz="1250" dirty="0"/>
           </a:p>
@@ -20074,7 +20053,7 @@
                 <a:ea typeface="Calibri" pitchFamily="34" charset="-122"/>
                 <a:cs typeface="Calibri" pitchFamily="34" charset="-120"/>
               </a:rPr>
-              <a:t>4 GHz bandwidth, 3 GHz centre. Full-band accuracy on every phantom with the array; the anchor for any hardware configuration.</a:t>
+              <a:t>4 GHz bandwidth, 3 GHz centre. Matched full-band accuracy on all three phantoms with the full array.</a:t>
             </a:r>
             <a:endParaRPr lang="en-US" sz="1150" dirty="0"/>
           </a:p>
@@ -20186,7 +20165,7 @@
                 <a:ea typeface="Calibri" pitchFamily="34" charset="-122"/>
                 <a:cs typeface="Calibri" pitchFamily="34" charset="-120"/>
               </a:rPr>
-              <a:t>3 GHz bandwidth costs only 1-3 points on the hardest phantom; 2-4 GHz is the floor (-7 on F5).</a:t>
+              <a:t>Scored 1-3 points below full band on F5; 2-4 GHz scored 7 below.</a:t>
             </a:r>
             <a:endParaRPr lang="en-US" sz="1150" dirty="0"/>
           </a:p>
@@ -20259,7 +20238,7 @@
                 <a:ea typeface="Cambria" pitchFamily="34" charset="-122"/>
                 <a:cs typeface="Cambria" pitchFamily="34" charset="-120"/>
               </a:rPr>
-              <a:t>Avoid: above 5 GHz and below 1 GHz alone</a:t>
+              <a:t>Low-scoring regions</a:t>
             </a:r>
             <a:endParaRPr lang="en-US" sz="1600" dirty="0"/>
           </a:p>
@@ -20298,7 +20277,7 @@
                 <a:ea typeface="Calibri" pitchFamily="34" charset="-122"/>
                 <a:cs typeface="Calibri" pitchFamily="34" charset="-120"/>
               </a:rPr>
-              <a:t>High bands carry no F5 information (insert attenuation). Pure low band collapses without array diversity.</a:t>
+              <a:t>F5: 71.7 / 69.7 at 4-6 / 6-8 GHz (full array); 25.3 at 0.1-2 GHz with one antenna.</a:t>
             </a:r>
             <a:endParaRPr lang="en-US" sz="1150" dirty="0"/>
           </a:p>
@@ -20371,7 +20350,7 @@
                 <a:ea typeface="Cambria" pitchFamily="34" charset="-122"/>
                 <a:cs typeface="Cambria" pitchFamily="34" charset="-120"/>
               </a:rPr>
-              <a:t>Design principle</a:t>
+              <a:t>Combined reductions at 1-5 GHz</a:t>
             </a:r>
             <a:endParaRPr lang="en-US" sz="1600" dirty="0"/>
           </a:p>
@@ -20410,7 +20389,7 @@
                 <a:ea typeface="Calibri" pitchFamily="34" charset="-122"/>
                 <a:cs typeface="Calibri" pitchFamily="34" charset="-120"/>
               </a:rPr>
-              <a:t>Antennas and bandwidth trade against each other. Cut one aggressively, not both: 4-ant reflection-only @ 1-5 GHz keeps 95% on F5.</a:t>
+              <a:t>F5: 94.9 (4-ant refl) / 92.9 (2-ant) / 84.8 (2-ant refl) / 69.7 (1 antenna).</a:t>
             </a:r>
             <a:endParaRPr lang="en-US" sz="1150" dirty="0"/>
           </a:p>

</xml_diff>

<commit_message>
Minimal-chip sweep: single-tone localization works; magnitude-only needs bandwidth; deck Part 4
Co-Authored-By: Claude Fable 5 <noreply@anthropic.com>
</commit_message>
<xml_diff>
--- a/presentation/Frequency_Reduction.pptx
+++ b/presentation/Frequency_Reduction.pptx
@@ -21,9 +21,10 @@
     <p:sldId id="269" r:id="rId15"/>
     <p:sldId id="270" r:id="rId16"/>
     <p:sldId id="271" r:id="rId17"/>
+    <p:sldId id="272" r:id="rId18"/>
   </p:sldIdLst>
   <p:notesMasterIdLst>
-    <p:notesMasterId r:id="rId18"/>
+    <p:notesMasterId r:id="rId19"/>
   </p:notesMasterIdLst>
   <p:sldSz cx="9144000" cy="5143500"/>
   <p:notesSz cx="5143500" cy="9144000"/>
@@ -1157,6 +1158,94 @@
             <a:fld id="{F7021451-1387-4CA6-816F-3879F97B5CBC}" type="slidenum">
               <a:rPr lang="en-US"/>
               <a:t>16</a:t>
+            </a:fld>
+            <a:endParaRPr lang="en-US"/>
+          </a:p>
+        </p:txBody>
+      </p:sp>
+    </p:spTree>
+    <p:extLst>
+      <p:ext uri="{BB962C8B-B14F-4D97-AF65-F5344CB8AC3E}">
+        <p14:creationId xmlns:p14="http://schemas.microsoft.com/office/powerpoint/2010/main" val="1024086991"/>
+      </p:ext>
+    </p:extLst>
+  </p:cSld>
+  <p:clrMapOvr>
+    <a:masterClrMapping/>
+  </p:clrMapOvr>
+</p:notes>
+</file>
+
+<file path=ppt/notesSlides/notesSlide17.xml><?xml version="1.0" encoding="utf-8"?>
+<p:notes xmlns:a="http://schemas.openxmlformats.org/drawingml/2006/main" xmlns:r="http://schemas.openxmlformats.org/officeDocument/2006/relationships" xmlns:p="http://schemas.openxmlformats.org/presentationml/2006/main">
+  <p:cSld>
+    <p:spTree>
+      <p:nvGrpSpPr>
+        <p:cNvPr id="1" name=""/>
+        <p:cNvGrpSpPr/>
+        <p:nvPr/>
+      </p:nvGrpSpPr>
+      <p:grpSpPr>
+        <a:xfrm>
+          <a:off x="0" y="0"/>
+          <a:ext cx="0" cy="0"/>
+          <a:chOff x="0" y="0"/>
+          <a:chExt cx="0" cy="0"/>
+        </a:xfrm>
+      </p:grpSpPr>
+      <p:sp>
+        <p:nvSpPr>
+          <p:cNvPr id="2" name="Slide Image Placeholder 1"/>
+          <p:cNvSpPr>
+            <a:spLocks noGrp="1" noRot="1" noChangeAspect="1"/>
+          </p:cNvSpPr>
+          <p:nvPr>
+            <p:ph type="sldImg"/>
+          </p:nvPr>
+        </p:nvSpPr>
+        <p:spPr/>
+      </p:sp>
+      <p:sp>
+        <p:nvSpPr>
+          <p:cNvPr id="3" name="Notes Placeholder 2"/>
+          <p:cNvSpPr>
+            <a:spLocks noGrp="1"/>
+          </p:cNvSpPr>
+          <p:nvPr>
+            <p:ph type="body" idx="1"/>
+          </p:nvPr>
+        </p:nvSpPr>
+        <p:spPr/>
+        <p:txBody>
+          <a:bodyPr/>
+          <a:lstStyle/>
+          <a:p>
+            <a:r>
+              <a:rPr lang="en-US" dirty="0"/>
+              <a:t/>
+            </a:r>
+            <a:endParaRPr lang="en-US" dirty="0"/>
+          </a:p>
+        </p:txBody>
+      </p:sp>
+      <p:sp>
+        <p:nvSpPr>
+          <p:cNvPr id="4" name="Slide Number Placeholder 3"/>
+          <p:cNvSpPr>
+            <a:spLocks noGrp="1"/>
+          </p:cNvSpPr>
+          <p:nvPr>
+            <p:ph type="sldNum" sz="quarter" idx="10"/>
+          </p:nvPr>
+        </p:nvSpPr>
+        <p:spPr/>
+        <p:txBody>
+          <a:bodyPr/>
+          <a:lstStyle/>
+          <a:p>
+            <a:fld id="{F7021451-1387-4CA6-816F-3879F97B5CBC}" type="slidenum">
+              <a:rPr lang="en-US"/>
+              <a:t>17</a:t>
             </a:fld>
             <a:endParaRPr lang="en-US"/>
           </a:p>
@@ -9775,6 +9864,206 @@
 </p:sld>
 </file>
 
+<file path=ppt/slides/slide17.xml><?xml version="1.0" encoding="utf-8"?>
+<p:sld xmlns:a="http://schemas.openxmlformats.org/drawingml/2006/main" xmlns:r="http://schemas.openxmlformats.org/officeDocument/2006/relationships" xmlns:p="http://schemas.openxmlformats.org/presentationml/2006/main">
+  <p:cSld name="Slide 17">
+    <p:bg>
+      <p:bgPr>
+        <a:solidFill>
+          <a:srgbClr val="FFFFFF"/>
+        </a:solidFill>
+      </p:bgPr>
+    </p:bg>
+    <p:spTree>
+      <p:nvGrpSpPr>
+        <p:cNvPr id="1" name=""/>
+        <p:cNvGrpSpPr/>
+        <p:nvPr/>
+      </p:nvGrpSpPr>
+      <p:grpSpPr>
+        <a:xfrm>
+          <a:off x="0" y="0"/>
+          <a:ext cx="0" cy="0"/>
+          <a:chOff x="0" y="0"/>
+          <a:chExt cx="0" cy="0"/>
+        </a:xfrm>
+      </p:grpSpPr>
+      <p:sp>
+        <p:nvSpPr>
+          <p:cNvPr id="2" name="Text 0"/>
+          <p:cNvSpPr/>
+          <p:nvPr/>
+        </p:nvSpPr>
+        <p:spPr>
+          <a:xfrm>
+            <a:off x="457200" y="237744"/>
+            <a:ext cx="8229600" cy="256032"/>
+          </a:xfrm>
+          <a:prstGeom prst="rect">
+            <a:avLst/>
+          </a:prstGeom>
+          <a:noFill/>
+          <a:ln/>
+        </p:spPr>
+        <p:txBody>
+          <a:bodyPr wrap="square" lIns="0" tIns="0" rIns="0" bIns="0" rtlCol="0" anchor="t"/>
+          <a:lstStyle/>
+          <a:p>
+            <a:pPr indent="0" marL="0">
+              <a:buNone/>
+            </a:pPr>
+            <a:r>
+              <a:rPr lang="en-US" sz="1200" b="1" spc="200" kern="0" dirty="0">
+                <a:solidFill>
+                  <a:srgbClr val="BE0000"/>
+                </a:solidFill>
+                <a:latin typeface="Calibri" pitchFamily="34" charset="0"/>
+                <a:ea typeface="Calibri" pitchFamily="34" charset="-122"/>
+                <a:cs typeface="Calibri" pitchFamily="34" charset="-120"/>
+              </a:rPr>
+              <a:t>PART 4 · FURTHER REDUCTION</a:t>
+            </a:r>
+            <a:endParaRPr lang="en-US" sz="1200" dirty="0"/>
+          </a:p>
+        </p:txBody>
+      </p:sp>
+      <p:sp>
+        <p:nvSpPr>
+          <p:cNvPr id="3" name="Text 1"/>
+          <p:cNvSpPr/>
+          <p:nvPr/>
+        </p:nvSpPr>
+        <p:spPr>
+          <a:xfrm>
+            <a:off x="457200" y="512064"/>
+            <a:ext cx="8229600" cy="548640"/>
+          </a:xfrm>
+          <a:prstGeom prst="rect">
+            <a:avLst/>
+          </a:prstGeom>
+          <a:noFill/>
+          <a:ln/>
+        </p:spPr>
+        <p:txBody>
+          <a:bodyPr wrap="square" lIns="0" tIns="0" rIns="0" bIns="0" rtlCol="0" anchor="t"/>
+          <a:lstStyle/>
+          <a:p>
+            <a:pPr indent="0" marL="0">
+              <a:buNone/>
+            </a:pPr>
+            <a:r>
+              <a:rPr lang="en-US" sz="2500" b="1" dirty="0">
+                <a:solidFill>
+                  <a:srgbClr val="2A1618"/>
+                </a:solidFill>
+                <a:latin typeface="Cambria" pitchFamily="34" charset="0"/>
+                <a:ea typeface="Cambria" pitchFamily="34" charset="-122"/>
+                <a:cs typeface="Cambria" pitchFamily="34" charset="-120"/>
+              </a:rPr>
+              <a:t>Tone-count descent and magnitude-only input</a:t>
+            </a:r>
+            <a:endParaRPr lang="en-US" sz="2500" dirty="0"/>
+          </a:p>
+        </p:txBody>
+      </p:sp>
+      <p:pic>
+        <p:nvPicPr>
+          <p:cNvPr id="4" name="Image 0" descr="assets/minimal_chip_map.png">    </p:cNvPr>
+          <p:cNvPicPr>
+            <a:picLocks noChangeAspect="1"/>
+          </p:cNvPicPr>
+          <p:nvPr/>
+        </p:nvPicPr>
+        <p:blipFill>
+          <a:blip r:embed="rId1"/>
+          <a:stretch>
+            <a:fillRect/>
+          </a:stretch>
+        </p:blipFill>
+        <p:spPr>
+          <a:xfrm>
+            <a:off x="822960" y="1371600"/>
+            <a:ext cx="7498080" cy="2414016"/>
+          </a:xfrm>
+          <a:prstGeom prst="rect">
+            <a:avLst/>
+          </a:prstGeom>
+        </p:spPr>
+      </p:pic>
+      <p:sp>
+        <p:nvSpPr>
+          <p:cNvPr id="5" name="Shape 2"/>
+          <p:cNvSpPr/>
+          <p:nvPr/>
+        </p:nvSpPr>
+        <p:spPr>
+          <a:xfrm>
+            <a:off x="457200" y="4023360"/>
+            <a:ext cx="8229600" cy="1051560"/>
+          </a:xfrm>
+          <a:prstGeom prst="roundRect">
+            <a:avLst>
+              <a:gd name="adj" fmla="val 5217"/>
+            </a:avLst>
+          </a:prstGeom>
+          <a:solidFill>
+            <a:srgbClr val="FBEDED"/>
+          </a:solidFill>
+          <a:ln w="12700">
+            <a:solidFill>
+              <a:srgbClr val="E8C4C4"/>
+            </a:solidFill>
+            <a:prstDash val="solid"/>
+          </a:ln>
+        </p:spPr>
+      </p:sp>
+      <p:sp>
+        <p:nvSpPr>
+          <p:cNvPr id="6" name="Text 3"/>
+          <p:cNvSpPr/>
+          <p:nvPr/>
+        </p:nvSpPr>
+        <p:spPr>
+          <a:xfrm>
+            <a:off x="658368" y="4023360"/>
+            <a:ext cx="7863840" cy="1051560"/>
+          </a:xfrm>
+          <a:prstGeom prst="rect">
+            <a:avLst/>
+          </a:prstGeom>
+          <a:noFill/>
+          <a:ln/>
+        </p:spPr>
+        <p:txBody>
+          <a:bodyPr wrap="square" lIns="0" tIns="0" rIns="0" bIns="0" rtlCol="0" anchor="ctr"/>
+          <a:lstStyle/>
+          <a:p>
+            <a:pPr indent="0" marL="0">
+              <a:buNone/>
+            </a:pPr>
+            <a:r>
+              <a:rPr lang="en-US" sz="1150" dirty="0">
+                <a:solidFill>
+                  <a:srgbClr val="2B2B2B"/>
+                </a:solidFill>
+                <a:latin typeface="Calibri" pitchFamily="34" charset="0"/>
+                <a:ea typeface="Calibri" pitchFamily="34" charset="-122"/>
+                <a:cs typeface="Calibri" pitchFamily="34" charset="-120"/>
+              </a:rPr>
+              <a:t>Configurations that had not crossed 50%, reduced further. Tone columns: 4 -&gt; 1 frequency points on the native 10 MHz grid (1 pt = a single CW tone). Mag-only rows use |S| only (no phase). Single-tone, mag+phase: empty 66.0 (1 ant) / 91.5 (2 ant refl); F4 60.9 / 90.4. Mag-only with one antenna: 87-99 at 1-4 GHz but below 50% by 0.05-0.25 GHz (30.1 / 35.9); with two antennas: 49.7 (empty) and 69.9 (F4) at a single tone.</a:t>
+            </a:r>
+            <a:endParaRPr lang="en-US" sz="1150" dirty="0"/>
+          </a:p>
+        </p:txBody>
+      </p:sp>
+    </p:spTree>
+  </p:cSld>
+  <p:clrMapOvr>
+    <a:masterClrMapping/>
+  </p:clrMapOvr>
+</p:sld>
+</file>
+
 <file path=ppt/slides/slide2.xml><?xml version="1.0" encoding="utf-8"?>
 <p:sld xmlns:a="http://schemas.openxmlformats.org/drawingml/2006/main" xmlns:r="http://schemas.openxmlformats.org/officeDocument/2006/relationships" xmlns:p="http://schemas.openxmlformats.org/presentationml/2006/main">
   <p:cSld name="Slide 2">

</xml_diff>